<commit_message>
Add deliverables doc and update presentation
Add 'Documentação HelpDesk - V01/HelpDesk_Entregaveis.docx' containing the V01 project deliverables, and update the existing 'HelpDesk_Apresentação.pptx' presentation. The commit introduces the new deliverables document and applies binary updates to the presentation slides to reflect recent changes.
</commit_message>
<xml_diff>
--- a/HelpDesk_Apresentação.pptx
+++ b/HelpDesk_Apresentação.pptx
@@ -5,18 +5,19 @@
     <p:sldMasterId id="2147483648" r:id="rId1"/>
   </p:sldMasterIdLst>
   <p:notesMasterIdLst>
-    <p:notesMasterId r:id="rId11"/>
+    <p:notesMasterId r:id="rId12"/>
   </p:notesMasterIdLst>
   <p:sldIdLst>
     <p:sldId id="256" r:id="rId2"/>
     <p:sldId id="265" r:id="rId3"/>
-    <p:sldId id="257" r:id="rId4"/>
-    <p:sldId id="258" r:id="rId5"/>
-    <p:sldId id="259" r:id="rId6"/>
-    <p:sldId id="260" r:id="rId7"/>
-    <p:sldId id="261" r:id="rId8"/>
-    <p:sldId id="262" r:id="rId9"/>
-    <p:sldId id="263" r:id="rId10"/>
+    <p:sldId id="266" r:id="rId4"/>
+    <p:sldId id="257" r:id="rId5"/>
+    <p:sldId id="258" r:id="rId6"/>
+    <p:sldId id="259" r:id="rId7"/>
+    <p:sldId id="260" r:id="rId8"/>
+    <p:sldId id="261" r:id="rId9"/>
+    <p:sldId id="262" r:id="rId10"/>
+    <p:sldId id="263" r:id="rId11"/>
   </p:sldIdLst>
   <p:sldSz cx="9144000" cy="5143500" type="screen16x9"/>
   <p:notesSz cx="5143500" cy="9144000"/>
@@ -329,6 +330,90 @@
 </p:notes>
 </file>
 
+<file path=ppt/notesSlides/notesSlide10.xml><?xml version="1.0" encoding="utf-8"?>
+<p:notes xmlns:a="http://schemas.openxmlformats.org/drawingml/2006/main" xmlns:r="http://schemas.openxmlformats.org/officeDocument/2006/relationships" xmlns:p="http://schemas.openxmlformats.org/presentationml/2006/main">
+  <p:cSld>
+    <p:spTree>
+      <p:nvGrpSpPr>
+        <p:cNvPr id="1" name=""/>
+        <p:cNvGrpSpPr/>
+        <p:nvPr/>
+      </p:nvGrpSpPr>
+      <p:grpSpPr>
+        <a:xfrm>
+          <a:off x="0" y="0"/>
+          <a:ext cx="0" cy="0"/>
+          <a:chOff x="0" y="0"/>
+          <a:chExt cx="0" cy="0"/>
+        </a:xfrm>
+      </p:grpSpPr>
+      <p:sp>
+        <p:nvSpPr>
+          <p:cNvPr id="2" name="Slide Image Placeholder 1"/>
+          <p:cNvSpPr>
+            <a:spLocks noGrp="1" noRot="1" noChangeAspect="1"/>
+          </p:cNvSpPr>
+          <p:nvPr>
+            <p:ph type="sldImg"/>
+          </p:nvPr>
+        </p:nvSpPr>
+        <p:spPr/>
+      </p:sp>
+      <p:sp>
+        <p:nvSpPr>
+          <p:cNvPr id="3" name="Notes Placeholder 2"/>
+          <p:cNvSpPr>
+            <a:spLocks noGrp="1"/>
+          </p:cNvSpPr>
+          <p:nvPr>
+            <p:ph type="body" idx="1"/>
+          </p:nvPr>
+        </p:nvSpPr>
+        <p:spPr/>
+        <p:txBody>
+          <a:bodyPr/>
+          <a:lstStyle/>
+          <a:p>
+            <a:endParaRPr lang="en-US" dirty="0"/>
+          </a:p>
+        </p:txBody>
+      </p:sp>
+      <p:sp>
+        <p:nvSpPr>
+          <p:cNvPr id="4" name="Slide Number Placeholder 3"/>
+          <p:cNvSpPr>
+            <a:spLocks noGrp="1"/>
+          </p:cNvSpPr>
+          <p:nvPr>
+            <p:ph type="sldNum" sz="quarter" idx="10"/>
+          </p:nvPr>
+        </p:nvSpPr>
+        <p:spPr/>
+        <p:txBody>
+          <a:bodyPr/>
+          <a:lstStyle/>
+          <a:p>
+            <a:fld id="{F7021451-1387-4CA6-816F-3879F97B5CBC}" type="slidenum">
+              <a:rPr lang="en-US"/>
+              <a:t>10</a:t>
+            </a:fld>
+            <a:endParaRPr lang="en-US"/>
+          </a:p>
+        </p:txBody>
+      </p:sp>
+    </p:spTree>
+    <p:extLst>
+      <p:ext uri="{BB962C8B-B14F-4D97-AF65-F5344CB8AC3E}">
+        <p14:creationId xmlns:p14="http://schemas.microsoft.com/office/powerpoint/2010/main" val="1024086991"/>
+      </p:ext>
+    </p:extLst>
+  </p:cSld>
+  <p:clrMapOvr>
+    <a:masterClrMapping/>
+  </p:clrMapOvr>
+</p:notes>
+</file>
+
 <file path=ppt/notesSlides/notesSlide2.xml><?xml version="1.0" encoding="utf-8"?>
 <p:notes xmlns:a="http://schemas.openxmlformats.org/drawingml/2006/main" xmlns:r="http://schemas.openxmlformats.org/officeDocument/2006/relationships" xmlns:p="http://schemas.openxmlformats.org/presentationml/2006/main">
   <p:cSld>
@@ -487,7 +572,7 @@
     </p:spTree>
     <p:extLst>
       <p:ext uri="{BB962C8B-B14F-4D97-AF65-F5344CB8AC3E}">
-        <p14:creationId xmlns:p14="http://schemas.microsoft.com/office/powerpoint/2010/main" val="1024086991"/>
+        <p14:creationId xmlns:p14="http://schemas.microsoft.com/office/powerpoint/2010/main" val="2861565015"/>
       </p:ext>
     </p:extLst>
   </p:cSld>
@@ -1776,7 +1861,7 @@
               <a:buNone/>
             </a:pPr>
             <a:r>
-              <a:rPr lang="en-US" sz="1200" dirty="0">
+              <a:rPr lang="en-US" sz="1200" dirty="0" smtClean="0">
                 <a:solidFill>
                   <a:srgbClr val="CADCFC"/>
                 </a:solidFill>
@@ -1784,7 +1869,7 @@
                 <a:ea typeface="Calibri" pitchFamily="34" charset="-122"/>
                 <a:cs typeface="Calibri" pitchFamily="34" charset="-120"/>
               </a:rPr>
-              <a:t>Fetch API</a:t>
+              <a:t>JS -Fetch API</a:t>
             </a:r>
             <a:endParaRPr lang="en-US" sz="1200" dirty="0"/>
           </a:p>
@@ -1843,6 +1928,1712 @@
               <a:buNone/>
             </a:pPr>
             <a:endParaRPr lang="en-US" sz="1200" dirty="0"/>
+          </a:p>
+        </p:txBody>
+      </p:sp>
+    </p:spTree>
+  </p:cSld>
+  <p:clrMapOvr>
+    <a:masterClrMapping/>
+  </p:clrMapOvr>
+</p:sld>
+</file>
+
+<file path=ppt/slides/slide10.xml><?xml version="1.0" encoding="utf-8"?>
+<p:sld xmlns:a="http://schemas.openxmlformats.org/drawingml/2006/main" xmlns:r="http://schemas.openxmlformats.org/officeDocument/2006/relationships" xmlns:p="http://schemas.openxmlformats.org/presentationml/2006/main">
+  <p:cSld name="Slide 8">
+    <p:bg>
+      <p:bgPr>
+        <a:solidFill>
+          <a:srgbClr val="F8F9FC"/>
+        </a:solidFill>
+        <a:effectLst/>
+      </p:bgPr>
+    </p:bg>
+    <p:spTree>
+      <p:nvGrpSpPr>
+        <p:cNvPr id="1" name=""/>
+        <p:cNvGrpSpPr/>
+        <p:nvPr/>
+      </p:nvGrpSpPr>
+      <p:grpSpPr>
+        <a:xfrm>
+          <a:off x="0" y="0"/>
+          <a:ext cx="0" cy="0"/>
+          <a:chOff x="0" y="0"/>
+          <a:chExt cx="0" cy="0"/>
+        </a:xfrm>
+      </p:grpSpPr>
+      <p:sp>
+        <p:nvSpPr>
+          <p:cNvPr id="2" name="Shape 0"/>
+          <p:cNvSpPr/>
+          <p:nvPr/>
+        </p:nvSpPr>
+        <p:spPr>
+          <a:xfrm>
+            <a:off x="0" y="0"/>
+            <a:ext cx="9144000" cy="685800"/>
+          </a:xfrm>
+          <a:prstGeom prst="rect">
+            <a:avLst/>
+          </a:prstGeom>
+          <a:solidFill>
+            <a:srgbClr val="2D3463"/>
+          </a:solidFill>
+          <a:ln w="12700">
+            <a:solidFill>
+              <a:srgbClr val="2D3463"/>
+            </a:solidFill>
+            <a:prstDash val="solid"/>
+          </a:ln>
+        </p:spPr>
+      </p:sp>
+      <p:sp>
+        <p:nvSpPr>
+          <p:cNvPr id="3" name="Text 1"/>
+          <p:cNvSpPr/>
+          <p:nvPr/>
+        </p:nvSpPr>
+        <p:spPr>
+          <a:xfrm>
+            <a:off x="365760" y="0"/>
+            <a:ext cx="8412480" cy="685800"/>
+          </a:xfrm>
+          <a:prstGeom prst="rect">
+            <a:avLst/>
+          </a:prstGeom>
+          <a:noFill/>
+          <a:ln/>
+        </p:spPr>
+        <p:txBody>
+          <a:bodyPr wrap="square" lIns="0" tIns="0" rIns="0" bIns="0" rtlCol="0" anchor="ctr"/>
+          <a:lstStyle/>
+          <a:p>
+            <a:pPr marL="0" indent="0">
+              <a:buNone/>
+            </a:pPr>
+            <a:r>
+              <a:rPr lang="en-US" sz="1600" b="1" dirty="0">
+                <a:solidFill>
+                  <a:srgbClr val="FFFFFF"/>
+                </a:solidFill>
+                <a:latin typeface="Calibri" pitchFamily="34" charset="0"/>
+                <a:ea typeface="Calibri" pitchFamily="34" charset="-122"/>
+                <a:cs typeface="Calibri" pitchFamily="34" charset="-120"/>
+              </a:rPr>
+              <a:t>PALETA DE CORES  &amp;  FLUXO DO CHAMADO</a:t>
+            </a:r>
+            <a:endParaRPr lang="en-US" sz="1600" dirty="0"/>
+          </a:p>
+        </p:txBody>
+      </p:sp>
+      <p:sp>
+        <p:nvSpPr>
+          <p:cNvPr id="4" name="Text 2"/>
+          <p:cNvSpPr/>
+          <p:nvPr/>
+        </p:nvSpPr>
+        <p:spPr>
+          <a:xfrm>
+            <a:off x="365760" y="822960"/>
+            <a:ext cx="8412480" cy="274320"/>
+          </a:xfrm>
+          <a:prstGeom prst="rect">
+            <a:avLst/>
+          </a:prstGeom>
+          <a:noFill/>
+          <a:ln/>
+        </p:spPr>
+        <p:txBody>
+          <a:bodyPr wrap="square" lIns="0" tIns="0" rIns="0" bIns="0" rtlCol="0" anchor="ctr"/>
+          <a:lstStyle/>
+          <a:p>
+            <a:pPr marL="0" indent="0">
+              <a:buNone/>
+            </a:pPr>
+            <a:r>
+              <a:rPr lang="en-US" sz="1100" b="1" dirty="0">
+                <a:solidFill>
+                  <a:srgbClr val="2D3463"/>
+                </a:solidFill>
+                <a:latin typeface="Calibri" pitchFamily="34" charset="0"/>
+                <a:ea typeface="Calibri" pitchFamily="34" charset="-122"/>
+                <a:cs typeface="Calibri" pitchFamily="34" charset="-120"/>
+              </a:rPr>
+              <a:t>Status dos Chamados (tabela chamados_status)</a:t>
+            </a:r>
+            <a:endParaRPr lang="en-US" sz="1100" dirty="0"/>
+          </a:p>
+        </p:txBody>
+      </p:sp>
+      <p:sp>
+        <p:nvSpPr>
+          <p:cNvPr id="5" name="Shape 3"/>
+          <p:cNvSpPr/>
+          <p:nvPr/>
+        </p:nvSpPr>
+        <p:spPr>
+          <a:xfrm>
+            <a:off x="365760" y="1152144"/>
+            <a:ext cx="1353312" cy="457200"/>
+          </a:xfrm>
+          <a:prstGeom prst="rect">
+            <a:avLst/>
+          </a:prstGeom>
+          <a:solidFill>
+            <a:srgbClr val="0D6EFD"/>
+          </a:solidFill>
+          <a:ln w="12700">
+            <a:solidFill>
+              <a:srgbClr val="0D6EFD"/>
+            </a:solidFill>
+            <a:prstDash val="solid"/>
+          </a:ln>
+        </p:spPr>
+      </p:sp>
+      <p:sp>
+        <p:nvSpPr>
+          <p:cNvPr id="6" name="Text 4"/>
+          <p:cNvSpPr/>
+          <p:nvPr/>
+        </p:nvSpPr>
+        <p:spPr>
+          <a:xfrm>
+            <a:off x="365760" y="1152144"/>
+            <a:ext cx="1353312" cy="274320"/>
+          </a:xfrm>
+          <a:prstGeom prst="rect">
+            <a:avLst/>
+          </a:prstGeom>
+          <a:noFill/>
+          <a:ln/>
+        </p:spPr>
+        <p:txBody>
+          <a:bodyPr wrap="square" lIns="0" tIns="0" rIns="0" bIns="0" rtlCol="0" anchor="ctr"/>
+          <a:lstStyle/>
+          <a:p>
+            <a:pPr marL="0" indent="0" algn="ctr">
+              <a:buNone/>
+            </a:pPr>
+            <a:r>
+              <a:rPr lang="en-US" sz="850" b="1" dirty="0">
+                <a:solidFill>
+                  <a:srgbClr val="FFFFFF"/>
+                </a:solidFill>
+                <a:latin typeface="Consolas" pitchFamily="34" charset="0"/>
+                <a:ea typeface="Consolas" pitchFamily="34" charset="-122"/>
+                <a:cs typeface="Consolas" pitchFamily="34" charset="-120"/>
+              </a:rPr>
+              <a:t>#0D6EFD</a:t>
+            </a:r>
+            <a:endParaRPr lang="en-US" sz="850" dirty="0"/>
+          </a:p>
+        </p:txBody>
+      </p:sp>
+      <p:sp>
+        <p:nvSpPr>
+          <p:cNvPr id="7" name="Text 5"/>
+          <p:cNvSpPr/>
+          <p:nvPr/>
+        </p:nvSpPr>
+        <p:spPr>
+          <a:xfrm>
+            <a:off x="365760" y="1426464"/>
+            <a:ext cx="1353312" cy="182880"/>
+          </a:xfrm>
+          <a:prstGeom prst="rect">
+            <a:avLst/>
+          </a:prstGeom>
+          <a:noFill/>
+          <a:ln/>
+        </p:spPr>
+        <p:txBody>
+          <a:bodyPr wrap="square" lIns="0" tIns="0" rIns="0" bIns="0" rtlCol="0" anchor="ctr"/>
+          <a:lstStyle/>
+          <a:p>
+            <a:pPr marL="0" indent="0" algn="ctr">
+              <a:buNone/>
+            </a:pPr>
+            <a:r>
+              <a:rPr lang="en-US" sz="750" dirty="0">
+                <a:solidFill>
+                  <a:srgbClr val="FFFFFF"/>
+                </a:solidFill>
+                <a:latin typeface="Calibri" pitchFamily="34" charset="0"/>
+                <a:ea typeface="Calibri" pitchFamily="34" charset="-122"/>
+                <a:cs typeface="Calibri" pitchFamily="34" charset="-120"/>
+              </a:rPr>
+              <a:t>Aberto</a:t>
+            </a:r>
+            <a:endParaRPr lang="en-US" sz="750" dirty="0"/>
+          </a:p>
+        </p:txBody>
+      </p:sp>
+      <p:sp>
+        <p:nvSpPr>
+          <p:cNvPr id="8" name="Shape 6"/>
+          <p:cNvSpPr/>
+          <p:nvPr/>
+        </p:nvSpPr>
+        <p:spPr>
+          <a:xfrm>
+            <a:off x="1810512" y="1152144"/>
+            <a:ext cx="1353312" cy="457200"/>
+          </a:xfrm>
+          <a:prstGeom prst="rect">
+            <a:avLst/>
+          </a:prstGeom>
+          <a:solidFill>
+            <a:srgbClr val="6F42C1"/>
+          </a:solidFill>
+          <a:ln w="12700">
+            <a:solidFill>
+              <a:srgbClr val="6F42C1"/>
+            </a:solidFill>
+            <a:prstDash val="solid"/>
+          </a:ln>
+        </p:spPr>
+      </p:sp>
+      <p:sp>
+        <p:nvSpPr>
+          <p:cNvPr id="9" name="Text 7"/>
+          <p:cNvSpPr/>
+          <p:nvPr/>
+        </p:nvSpPr>
+        <p:spPr>
+          <a:xfrm>
+            <a:off x="1810512" y="1152144"/>
+            <a:ext cx="1353312" cy="274320"/>
+          </a:xfrm>
+          <a:prstGeom prst="rect">
+            <a:avLst/>
+          </a:prstGeom>
+          <a:noFill/>
+          <a:ln/>
+        </p:spPr>
+        <p:txBody>
+          <a:bodyPr wrap="square" lIns="0" tIns="0" rIns="0" bIns="0" rtlCol="0" anchor="ctr"/>
+          <a:lstStyle/>
+          <a:p>
+            <a:pPr marL="0" indent="0" algn="ctr">
+              <a:buNone/>
+            </a:pPr>
+            <a:r>
+              <a:rPr lang="en-US" sz="850" b="1" dirty="0">
+                <a:solidFill>
+                  <a:srgbClr val="FFFFFF"/>
+                </a:solidFill>
+                <a:latin typeface="Consolas" pitchFamily="34" charset="0"/>
+                <a:ea typeface="Consolas" pitchFamily="34" charset="-122"/>
+                <a:cs typeface="Consolas" pitchFamily="34" charset="-120"/>
+              </a:rPr>
+              <a:t>#6F42C1</a:t>
+            </a:r>
+            <a:endParaRPr lang="en-US" sz="850" dirty="0"/>
+          </a:p>
+        </p:txBody>
+      </p:sp>
+      <p:sp>
+        <p:nvSpPr>
+          <p:cNvPr id="10" name="Text 8"/>
+          <p:cNvSpPr/>
+          <p:nvPr/>
+        </p:nvSpPr>
+        <p:spPr>
+          <a:xfrm>
+            <a:off x="1810512" y="1426464"/>
+            <a:ext cx="1353312" cy="182880"/>
+          </a:xfrm>
+          <a:prstGeom prst="rect">
+            <a:avLst/>
+          </a:prstGeom>
+          <a:noFill/>
+          <a:ln/>
+        </p:spPr>
+        <p:txBody>
+          <a:bodyPr wrap="square" lIns="0" tIns="0" rIns="0" bIns="0" rtlCol="0" anchor="ctr"/>
+          <a:lstStyle/>
+          <a:p>
+            <a:pPr marL="0" indent="0" algn="ctr">
+              <a:buNone/>
+            </a:pPr>
+            <a:r>
+              <a:rPr lang="en-US" sz="750" dirty="0">
+                <a:solidFill>
+                  <a:srgbClr val="FFFFFF"/>
+                </a:solidFill>
+                <a:latin typeface="Calibri" pitchFamily="34" charset="0"/>
+                <a:ea typeface="Calibri" pitchFamily="34" charset="-122"/>
+                <a:cs typeface="Calibri" pitchFamily="34" charset="-120"/>
+              </a:rPr>
+              <a:t>Em análise</a:t>
+            </a:r>
+            <a:endParaRPr lang="en-US" sz="750" dirty="0"/>
+          </a:p>
+        </p:txBody>
+      </p:sp>
+      <p:sp>
+        <p:nvSpPr>
+          <p:cNvPr id="11" name="Shape 9"/>
+          <p:cNvSpPr/>
+          <p:nvPr/>
+        </p:nvSpPr>
+        <p:spPr>
+          <a:xfrm>
+            <a:off x="3255264" y="1152144"/>
+            <a:ext cx="1353312" cy="457200"/>
+          </a:xfrm>
+          <a:prstGeom prst="rect">
+            <a:avLst/>
+          </a:prstGeom>
+          <a:solidFill>
+            <a:srgbClr val="20C997"/>
+          </a:solidFill>
+          <a:ln w="12700">
+            <a:solidFill>
+              <a:srgbClr val="20C997"/>
+            </a:solidFill>
+            <a:prstDash val="solid"/>
+          </a:ln>
+        </p:spPr>
+      </p:sp>
+      <p:sp>
+        <p:nvSpPr>
+          <p:cNvPr id="12" name="Text 10"/>
+          <p:cNvSpPr/>
+          <p:nvPr/>
+        </p:nvSpPr>
+        <p:spPr>
+          <a:xfrm>
+            <a:off x="3255264" y="1152144"/>
+            <a:ext cx="1353312" cy="274320"/>
+          </a:xfrm>
+          <a:prstGeom prst="rect">
+            <a:avLst/>
+          </a:prstGeom>
+          <a:noFill/>
+          <a:ln/>
+        </p:spPr>
+        <p:txBody>
+          <a:bodyPr wrap="square" lIns="0" tIns="0" rIns="0" bIns="0" rtlCol="0" anchor="ctr"/>
+          <a:lstStyle/>
+          <a:p>
+            <a:pPr marL="0" indent="0" algn="ctr">
+              <a:buNone/>
+            </a:pPr>
+            <a:r>
+              <a:rPr lang="en-US" sz="850" b="1" dirty="0">
+                <a:solidFill>
+                  <a:srgbClr val="FFFFFF"/>
+                </a:solidFill>
+                <a:latin typeface="Consolas" pitchFamily="34" charset="0"/>
+                <a:ea typeface="Consolas" pitchFamily="34" charset="-122"/>
+                <a:cs typeface="Consolas" pitchFamily="34" charset="-120"/>
+              </a:rPr>
+              <a:t>#20C997</a:t>
+            </a:r>
+            <a:endParaRPr lang="en-US" sz="850" dirty="0"/>
+          </a:p>
+        </p:txBody>
+      </p:sp>
+      <p:sp>
+        <p:nvSpPr>
+          <p:cNvPr id="13" name="Text 11"/>
+          <p:cNvSpPr/>
+          <p:nvPr/>
+        </p:nvSpPr>
+        <p:spPr>
+          <a:xfrm>
+            <a:off x="3255264" y="1426464"/>
+            <a:ext cx="1353312" cy="182880"/>
+          </a:xfrm>
+          <a:prstGeom prst="rect">
+            <a:avLst/>
+          </a:prstGeom>
+          <a:noFill/>
+          <a:ln/>
+        </p:spPr>
+        <p:txBody>
+          <a:bodyPr wrap="square" lIns="0" tIns="0" rIns="0" bIns="0" rtlCol="0" anchor="ctr"/>
+          <a:lstStyle/>
+          <a:p>
+            <a:pPr marL="0" indent="0" algn="ctr">
+              <a:buNone/>
+            </a:pPr>
+            <a:r>
+              <a:rPr lang="en-US" sz="750" dirty="0">
+                <a:solidFill>
+                  <a:srgbClr val="FFFFFF"/>
+                </a:solidFill>
+                <a:latin typeface="Calibri" pitchFamily="34" charset="0"/>
+                <a:ea typeface="Calibri" pitchFamily="34" charset="-122"/>
+                <a:cs typeface="Calibri" pitchFamily="34" charset="-120"/>
+              </a:rPr>
+              <a:t>Em atendimento</a:t>
+            </a:r>
+            <a:endParaRPr lang="en-US" sz="750" dirty="0"/>
+          </a:p>
+        </p:txBody>
+      </p:sp>
+      <p:sp>
+        <p:nvSpPr>
+          <p:cNvPr id="14" name="Shape 12"/>
+          <p:cNvSpPr/>
+          <p:nvPr/>
+        </p:nvSpPr>
+        <p:spPr>
+          <a:xfrm>
+            <a:off x="4700016" y="1152144"/>
+            <a:ext cx="1353312" cy="457200"/>
+          </a:xfrm>
+          <a:prstGeom prst="rect">
+            <a:avLst/>
+          </a:prstGeom>
+          <a:solidFill>
+            <a:srgbClr val="FD7E14"/>
+          </a:solidFill>
+          <a:ln w="12700">
+            <a:solidFill>
+              <a:srgbClr val="FD7E14"/>
+            </a:solidFill>
+            <a:prstDash val="solid"/>
+          </a:ln>
+        </p:spPr>
+      </p:sp>
+      <p:sp>
+        <p:nvSpPr>
+          <p:cNvPr id="15" name="Text 13"/>
+          <p:cNvSpPr/>
+          <p:nvPr/>
+        </p:nvSpPr>
+        <p:spPr>
+          <a:xfrm>
+            <a:off x="4700016" y="1152144"/>
+            <a:ext cx="1353312" cy="274320"/>
+          </a:xfrm>
+          <a:prstGeom prst="rect">
+            <a:avLst/>
+          </a:prstGeom>
+          <a:noFill/>
+          <a:ln/>
+        </p:spPr>
+        <p:txBody>
+          <a:bodyPr wrap="square" lIns="0" tIns="0" rIns="0" bIns="0" rtlCol="0" anchor="ctr"/>
+          <a:lstStyle/>
+          <a:p>
+            <a:pPr marL="0" indent="0" algn="ctr">
+              <a:buNone/>
+            </a:pPr>
+            <a:r>
+              <a:rPr lang="en-US" sz="850" b="1" dirty="0">
+                <a:solidFill>
+                  <a:srgbClr val="FFFFFF"/>
+                </a:solidFill>
+                <a:latin typeface="Consolas" pitchFamily="34" charset="0"/>
+                <a:ea typeface="Consolas" pitchFamily="34" charset="-122"/>
+                <a:cs typeface="Consolas" pitchFamily="34" charset="-120"/>
+              </a:rPr>
+              <a:t>#FD7E14</a:t>
+            </a:r>
+            <a:endParaRPr lang="en-US" sz="850" dirty="0"/>
+          </a:p>
+        </p:txBody>
+      </p:sp>
+      <p:sp>
+        <p:nvSpPr>
+          <p:cNvPr id="16" name="Text 14"/>
+          <p:cNvSpPr/>
+          <p:nvPr/>
+        </p:nvSpPr>
+        <p:spPr>
+          <a:xfrm>
+            <a:off x="4700016" y="1426464"/>
+            <a:ext cx="1353312" cy="182880"/>
+          </a:xfrm>
+          <a:prstGeom prst="rect">
+            <a:avLst/>
+          </a:prstGeom>
+          <a:noFill/>
+          <a:ln/>
+        </p:spPr>
+        <p:txBody>
+          <a:bodyPr wrap="square" lIns="0" tIns="0" rIns="0" bIns="0" rtlCol="0" anchor="ctr"/>
+          <a:lstStyle/>
+          <a:p>
+            <a:pPr marL="0" indent="0" algn="ctr">
+              <a:buNone/>
+            </a:pPr>
+            <a:r>
+              <a:rPr lang="en-US" sz="750" dirty="0">
+                <a:solidFill>
+                  <a:srgbClr val="FFFFFF"/>
+                </a:solidFill>
+                <a:latin typeface="Calibri" pitchFamily="34" charset="0"/>
+                <a:ea typeface="Calibri" pitchFamily="34" charset="-122"/>
+                <a:cs typeface="Calibri" pitchFamily="34" charset="-120"/>
+              </a:rPr>
+              <a:t>Aguardando cliente</a:t>
+            </a:r>
+            <a:endParaRPr lang="en-US" sz="750" dirty="0"/>
+          </a:p>
+        </p:txBody>
+      </p:sp>
+      <p:sp>
+        <p:nvSpPr>
+          <p:cNvPr id="17" name="Shape 15"/>
+          <p:cNvSpPr/>
+          <p:nvPr/>
+        </p:nvSpPr>
+        <p:spPr>
+          <a:xfrm>
+            <a:off x="6144768" y="1152144"/>
+            <a:ext cx="1353312" cy="457200"/>
+          </a:xfrm>
+          <a:prstGeom prst="rect">
+            <a:avLst/>
+          </a:prstGeom>
+          <a:solidFill>
+            <a:srgbClr val="198754"/>
+          </a:solidFill>
+          <a:ln w="12700">
+            <a:solidFill>
+              <a:srgbClr val="198754"/>
+            </a:solidFill>
+            <a:prstDash val="solid"/>
+          </a:ln>
+        </p:spPr>
+      </p:sp>
+      <p:sp>
+        <p:nvSpPr>
+          <p:cNvPr id="18" name="Text 16"/>
+          <p:cNvSpPr/>
+          <p:nvPr/>
+        </p:nvSpPr>
+        <p:spPr>
+          <a:xfrm>
+            <a:off x="6144768" y="1152144"/>
+            <a:ext cx="1353312" cy="274320"/>
+          </a:xfrm>
+          <a:prstGeom prst="rect">
+            <a:avLst/>
+          </a:prstGeom>
+          <a:noFill/>
+          <a:ln/>
+        </p:spPr>
+        <p:txBody>
+          <a:bodyPr wrap="square" lIns="0" tIns="0" rIns="0" bIns="0" rtlCol="0" anchor="ctr"/>
+          <a:lstStyle/>
+          <a:p>
+            <a:pPr marL="0" indent="0" algn="ctr">
+              <a:buNone/>
+            </a:pPr>
+            <a:r>
+              <a:rPr lang="en-US" sz="850" b="1" dirty="0">
+                <a:solidFill>
+                  <a:srgbClr val="FFFFFF"/>
+                </a:solidFill>
+                <a:latin typeface="Consolas" pitchFamily="34" charset="0"/>
+                <a:ea typeface="Consolas" pitchFamily="34" charset="-122"/>
+                <a:cs typeface="Consolas" pitchFamily="34" charset="-120"/>
+              </a:rPr>
+              <a:t>#198754</a:t>
+            </a:r>
+            <a:endParaRPr lang="en-US" sz="850" dirty="0"/>
+          </a:p>
+        </p:txBody>
+      </p:sp>
+      <p:sp>
+        <p:nvSpPr>
+          <p:cNvPr id="19" name="Text 17"/>
+          <p:cNvSpPr/>
+          <p:nvPr/>
+        </p:nvSpPr>
+        <p:spPr>
+          <a:xfrm>
+            <a:off x="6144768" y="1426464"/>
+            <a:ext cx="1353312" cy="182880"/>
+          </a:xfrm>
+          <a:prstGeom prst="rect">
+            <a:avLst/>
+          </a:prstGeom>
+          <a:noFill/>
+          <a:ln/>
+        </p:spPr>
+        <p:txBody>
+          <a:bodyPr wrap="square" lIns="0" tIns="0" rIns="0" bIns="0" rtlCol="0" anchor="ctr"/>
+          <a:lstStyle/>
+          <a:p>
+            <a:pPr marL="0" indent="0" algn="ctr">
+              <a:buNone/>
+            </a:pPr>
+            <a:r>
+              <a:rPr lang="en-US" sz="750" dirty="0">
+                <a:solidFill>
+                  <a:srgbClr val="FFFFFF"/>
+                </a:solidFill>
+                <a:latin typeface="Calibri" pitchFamily="34" charset="0"/>
+                <a:ea typeface="Calibri" pitchFamily="34" charset="-122"/>
+                <a:cs typeface="Calibri" pitchFamily="34" charset="-120"/>
+              </a:rPr>
+              <a:t>Resolvido</a:t>
+            </a:r>
+            <a:endParaRPr lang="en-US" sz="750" dirty="0"/>
+          </a:p>
+        </p:txBody>
+      </p:sp>
+      <p:sp>
+        <p:nvSpPr>
+          <p:cNvPr id="20" name="Shape 18"/>
+          <p:cNvSpPr/>
+          <p:nvPr/>
+        </p:nvSpPr>
+        <p:spPr>
+          <a:xfrm>
+            <a:off x="7589520" y="1152144"/>
+            <a:ext cx="1353312" cy="457200"/>
+          </a:xfrm>
+          <a:prstGeom prst="rect">
+            <a:avLst/>
+          </a:prstGeom>
+          <a:solidFill>
+            <a:srgbClr val="6C757D"/>
+          </a:solidFill>
+          <a:ln w="12700">
+            <a:solidFill>
+              <a:srgbClr val="6C757D"/>
+            </a:solidFill>
+            <a:prstDash val="solid"/>
+          </a:ln>
+        </p:spPr>
+      </p:sp>
+      <p:sp>
+        <p:nvSpPr>
+          <p:cNvPr id="21" name="Text 19"/>
+          <p:cNvSpPr/>
+          <p:nvPr/>
+        </p:nvSpPr>
+        <p:spPr>
+          <a:xfrm>
+            <a:off x="7589520" y="1152144"/>
+            <a:ext cx="1353312" cy="274320"/>
+          </a:xfrm>
+          <a:prstGeom prst="rect">
+            <a:avLst/>
+          </a:prstGeom>
+          <a:noFill/>
+          <a:ln/>
+        </p:spPr>
+        <p:txBody>
+          <a:bodyPr wrap="square" lIns="0" tIns="0" rIns="0" bIns="0" rtlCol="0" anchor="ctr"/>
+          <a:lstStyle/>
+          <a:p>
+            <a:pPr marL="0" indent="0" algn="ctr">
+              <a:buNone/>
+            </a:pPr>
+            <a:r>
+              <a:rPr lang="en-US" sz="850" b="1" dirty="0">
+                <a:solidFill>
+                  <a:srgbClr val="FFFFFF"/>
+                </a:solidFill>
+                <a:latin typeface="Consolas" pitchFamily="34" charset="0"/>
+                <a:ea typeface="Consolas" pitchFamily="34" charset="-122"/>
+                <a:cs typeface="Consolas" pitchFamily="34" charset="-120"/>
+              </a:rPr>
+              <a:t>#6C757D</a:t>
+            </a:r>
+            <a:endParaRPr lang="en-US" sz="850" dirty="0"/>
+          </a:p>
+        </p:txBody>
+      </p:sp>
+      <p:sp>
+        <p:nvSpPr>
+          <p:cNvPr id="22" name="Text 20"/>
+          <p:cNvSpPr/>
+          <p:nvPr/>
+        </p:nvSpPr>
+        <p:spPr>
+          <a:xfrm>
+            <a:off x="7589520" y="1426464"/>
+            <a:ext cx="1353312" cy="182880"/>
+          </a:xfrm>
+          <a:prstGeom prst="rect">
+            <a:avLst/>
+          </a:prstGeom>
+          <a:noFill/>
+          <a:ln/>
+        </p:spPr>
+        <p:txBody>
+          <a:bodyPr wrap="square" lIns="0" tIns="0" rIns="0" bIns="0" rtlCol="0" anchor="ctr"/>
+          <a:lstStyle/>
+          <a:p>
+            <a:pPr marL="0" indent="0" algn="ctr">
+              <a:buNone/>
+            </a:pPr>
+            <a:r>
+              <a:rPr lang="en-US" sz="750" dirty="0">
+                <a:solidFill>
+                  <a:srgbClr val="FFFFFF"/>
+                </a:solidFill>
+                <a:latin typeface="Calibri" pitchFamily="34" charset="0"/>
+                <a:ea typeface="Calibri" pitchFamily="34" charset="-122"/>
+                <a:cs typeface="Calibri" pitchFamily="34" charset="-120"/>
+              </a:rPr>
+              <a:t>Fechado</a:t>
+            </a:r>
+            <a:endParaRPr lang="en-US" sz="750" dirty="0"/>
+          </a:p>
+        </p:txBody>
+      </p:sp>
+      <p:sp>
+        <p:nvSpPr>
+          <p:cNvPr id="23" name="Text 21"/>
+          <p:cNvSpPr/>
+          <p:nvPr/>
+        </p:nvSpPr>
+        <p:spPr>
+          <a:xfrm>
+            <a:off x="365760" y="1719072"/>
+            <a:ext cx="8412480" cy="237744"/>
+          </a:xfrm>
+          <a:prstGeom prst="rect">
+            <a:avLst/>
+          </a:prstGeom>
+          <a:noFill/>
+          <a:ln/>
+        </p:spPr>
+        <p:txBody>
+          <a:bodyPr wrap="square" lIns="0" tIns="0" rIns="0" bIns="0" rtlCol="0" anchor="ctr"/>
+          <a:lstStyle/>
+          <a:p>
+            <a:pPr marL="0" indent="0">
+              <a:buNone/>
+            </a:pPr>
+            <a:r>
+              <a:rPr lang="en-US" sz="1100" b="1" dirty="0">
+                <a:solidFill>
+                  <a:srgbClr val="2D3463"/>
+                </a:solidFill>
+                <a:latin typeface="Calibri" pitchFamily="34" charset="0"/>
+                <a:ea typeface="Calibri" pitchFamily="34" charset="-122"/>
+                <a:cs typeface="Calibri" pitchFamily="34" charset="-120"/>
+              </a:rPr>
+              <a:t>Prioridades</a:t>
+            </a:r>
+            <a:endParaRPr lang="en-US" sz="1100" dirty="0"/>
+          </a:p>
+        </p:txBody>
+      </p:sp>
+      <p:sp>
+        <p:nvSpPr>
+          <p:cNvPr id="24" name="Shape 22"/>
+          <p:cNvSpPr/>
+          <p:nvPr/>
+        </p:nvSpPr>
+        <p:spPr>
+          <a:xfrm>
+            <a:off x="365760" y="1993392"/>
+            <a:ext cx="2066544" cy="420624"/>
+          </a:xfrm>
+          <a:prstGeom prst="rect">
+            <a:avLst/>
+          </a:prstGeom>
+          <a:solidFill>
+            <a:srgbClr val="6C757D"/>
+          </a:solidFill>
+          <a:ln w="12700">
+            <a:solidFill>
+              <a:srgbClr val="6C757D"/>
+            </a:solidFill>
+            <a:prstDash val="solid"/>
+          </a:ln>
+        </p:spPr>
+      </p:sp>
+      <p:sp>
+        <p:nvSpPr>
+          <p:cNvPr id="25" name="Text 23"/>
+          <p:cNvSpPr/>
+          <p:nvPr/>
+        </p:nvSpPr>
+        <p:spPr>
+          <a:xfrm>
+            <a:off x="365760" y="1993392"/>
+            <a:ext cx="2066544" cy="420624"/>
+          </a:xfrm>
+          <a:prstGeom prst="rect">
+            <a:avLst/>
+          </a:prstGeom>
+          <a:noFill/>
+          <a:ln/>
+        </p:spPr>
+        <p:txBody>
+          <a:bodyPr wrap="square" lIns="0" tIns="0" rIns="0" bIns="0" rtlCol="0" anchor="ctr"/>
+          <a:lstStyle/>
+          <a:p>
+            <a:pPr marL="0" indent="0" algn="ctr">
+              <a:buNone/>
+            </a:pPr>
+            <a:r>
+              <a:rPr lang="en-US" sz="1000" b="1" dirty="0">
+                <a:solidFill>
+                  <a:srgbClr val="FFFFFF"/>
+                </a:solidFill>
+                <a:latin typeface="Calibri" pitchFamily="34" charset="0"/>
+                <a:ea typeface="Calibri" pitchFamily="34" charset="-122"/>
+                <a:cs typeface="Calibri" pitchFamily="34" charset="-120"/>
+              </a:rPr>
+              <a:t>#6C757D  ·  Baixa</a:t>
+            </a:r>
+            <a:endParaRPr lang="en-US" sz="1000" dirty="0"/>
+          </a:p>
+        </p:txBody>
+      </p:sp>
+      <p:sp>
+        <p:nvSpPr>
+          <p:cNvPr id="26" name="Shape 24"/>
+          <p:cNvSpPr/>
+          <p:nvPr/>
+        </p:nvSpPr>
+        <p:spPr>
+          <a:xfrm>
+            <a:off x="2523744" y="1993392"/>
+            <a:ext cx="2066544" cy="420624"/>
+          </a:xfrm>
+          <a:prstGeom prst="rect">
+            <a:avLst/>
+          </a:prstGeom>
+          <a:solidFill>
+            <a:srgbClr val="0D6EFD"/>
+          </a:solidFill>
+          <a:ln w="12700">
+            <a:solidFill>
+              <a:srgbClr val="0D6EFD"/>
+            </a:solidFill>
+            <a:prstDash val="solid"/>
+          </a:ln>
+        </p:spPr>
+      </p:sp>
+      <p:sp>
+        <p:nvSpPr>
+          <p:cNvPr id="27" name="Text 25"/>
+          <p:cNvSpPr/>
+          <p:nvPr/>
+        </p:nvSpPr>
+        <p:spPr>
+          <a:xfrm>
+            <a:off x="2523744" y="1993392"/>
+            <a:ext cx="2066544" cy="420624"/>
+          </a:xfrm>
+          <a:prstGeom prst="rect">
+            <a:avLst/>
+          </a:prstGeom>
+          <a:noFill/>
+          <a:ln/>
+        </p:spPr>
+        <p:txBody>
+          <a:bodyPr wrap="square" lIns="0" tIns="0" rIns="0" bIns="0" rtlCol="0" anchor="ctr"/>
+          <a:lstStyle/>
+          <a:p>
+            <a:pPr marL="0" indent="0" algn="ctr">
+              <a:buNone/>
+            </a:pPr>
+            <a:r>
+              <a:rPr lang="en-US" sz="1000" b="1" dirty="0">
+                <a:solidFill>
+                  <a:srgbClr val="FFFFFF"/>
+                </a:solidFill>
+                <a:latin typeface="Calibri" pitchFamily="34" charset="0"/>
+                <a:ea typeface="Calibri" pitchFamily="34" charset="-122"/>
+                <a:cs typeface="Calibri" pitchFamily="34" charset="-120"/>
+              </a:rPr>
+              <a:t>#0D6EFD  ·  Média</a:t>
+            </a:r>
+            <a:endParaRPr lang="en-US" sz="1000" dirty="0"/>
+          </a:p>
+        </p:txBody>
+      </p:sp>
+      <p:sp>
+        <p:nvSpPr>
+          <p:cNvPr id="28" name="Shape 26"/>
+          <p:cNvSpPr/>
+          <p:nvPr/>
+        </p:nvSpPr>
+        <p:spPr>
+          <a:xfrm>
+            <a:off x="4681728" y="1993392"/>
+            <a:ext cx="2066544" cy="420624"/>
+          </a:xfrm>
+          <a:prstGeom prst="rect">
+            <a:avLst/>
+          </a:prstGeom>
+          <a:solidFill>
+            <a:srgbClr val="FD7E14"/>
+          </a:solidFill>
+          <a:ln w="12700">
+            <a:solidFill>
+              <a:srgbClr val="FD7E14"/>
+            </a:solidFill>
+            <a:prstDash val="solid"/>
+          </a:ln>
+        </p:spPr>
+      </p:sp>
+      <p:sp>
+        <p:nvSpPr>
+          <p:cNvPr id="29" name="Text 27"/>
+          <p:cNvSpPr/>
+          <p:nvPr/>
+        </p:nvSpPr>
+        <p:spPr>
+          <a:xfrm>
+            <a:off x="4681728" y="1993392"/>
+            <a:ext cx="2066544" cy="420624"/>
+          </a:xfrm>
+          <a:prstGeom prst="rect">
+            <a:avLst/>
+          </a:prstGeom>
+          <a:noFill/>
+          <a:ln/>
+        </p:spPr>
+        <p:txBody>
+          <a:bodyPr wrap="square" lIns="0" tIns="0" rIns="0" bIns="0" rtlCol="0" anchor="ctr"/>
+          <a:lstStyle/>
+          <a:p>
+            <a:pPr marL="0" indent="0" algn="ctr">
+              <a:buNone/>
+            </a:pPr>
+            <a:r>
+              <a:rPr lang="en-US" sz="1000" b="1" dirty="0">
+                <a:solidFill>
+                  <a:srgbClr val="FFFFFF"/>
+                </a:solidFill>
+                <a:latin typeface="Calibri" pitchFamily="34" charset="0"/>
+                <a:ea typeface="Calibri" pitchFamily="34" charset="-122"/>
+                <a:cs typeface="Calibri" pitchFamily="34" charset="-120"/>
+              </a:rPr>
+              <a:t>#FD7E14  ·  Alta</a:t>
+            </a:r>
+            <a:endParaRPr lang="en-US" sz="1000" dirty="0"/>
+          </a:p>
+        </p:txBody>
+      </p:sp>
+      <p:sp>
+        <p:nvSpPr>
+          <p:cNvPr id="30" name="Shape 28"/>
+          <p:cNvSpPr/>
+          <p:nvPr/>
+        </p:nvSpPr>
+        <p:spPr>
+          <a:xfrm>
+            <a:off x="6839712" y="1993392"/>
+            <a:ext cx="2066544" cy="420624"/>
+          </a:xfrm>
+          <a:prstGeom prst="rect">
+            <a:avLst/>
+          </a:prstGeom>
+          <a:solidFill>
+            <a:srgbClr val="DC3545"/>
+          </a:solidFill>
+          <a:ln w="12700">
+            <a:solidFill>
+              <a:srgbClr val="DC3545"/>
+            </a:solidFill>
+            <a:prstDash val="solid"/>
+          </a:ln>
+        </p:spPr>
+      </p:sp>
+      <p:sp>
+        <p:nvSpPr>
+          <p:cNvPr id="31" name="Text 29"/>
+          <p:cNvSpPr/>
+          <p:nvPr/>
+        </p:nvSpPr>
+        <p:spPr>
+          <a:xfrm>
+            <a:off x="6839712" y="1993392"/>
+            <a:ext cx="2066544" cy="420624"/>
+          </a:xfrm>
+          <a:prstGeom prst="rect">
+            <a:avLst/>
+          </a:prstGeom>
+          <a:noFill/>
+          <a:ln/>
+        </p:spPr>
+        <p:txBody>
+          <a:bodyPr wrap="square" lIns="0" tIns="0" rIns="0" bIns="0" rtlCol="0" anchor="ctr"/>
+          <a:lstStyle/>
+          <a:p>
+            <a:pPr marL="0" indent="0" algn="ctr">
+              <a:buNone/>
+            </a:pPr>
+            <a:r>
+              <a:rPr lang="en-US" sz="1000" b="1" dirty="0">
+                <a:solidFill>
+                  <a:srgbClr val="FFFFFF"/>
+                </a:solidFill>
+                <a:latin typeface="Calibri" pitchFamily="34" charset="0"/>
+                <a:ea typeface="Calibri" pitchFamily="34" charset="-122"/>
+                <a:cs typeface="Calibri" pitchFamily="34" charset="-120"/>
+              </a:rPr>
+              <a:t>#DC3545  ·  Urgente</a:t>
+            </a:r>
+            <a:endParaRPr lang="en-US" sz="1000" dirty="0"/>
+          </a:p>
+        </p:txBody>
+      </p:sp>
+      <p:sp>
+        <p:nvSpPr>
+          <p:cNvPr id="50" name="Text 48"/>
+          <p:cNvSpPr/>
+          <p:nvPr/>
+        </p:nvSpPr>
+        <p:spPr>
+          <a:xfrm>
+            <a:off x="365760" y="4041648"/>
+            <a:ext cx="8412480" cy="256032"/>
+          </a:xfrm>
+          <a:prstGeom prst="rect">
+            <a:avLst/>
+          </a:prstGeom>
+          <a:noFill/>
+          <a:ln/>
+        </p:spPr>
+        <p:txBody>
+          <a:bodyPr wrap="square" lIns="0" tIns="0" rIns="0" bIns="0" rtlCol="0" anchor="ctr"/>
+          <a:lstStyle/>
+          <a:p>
+            <a:pPr marL="0" indent="0">
+              <a:buNone/>
+            </a:pPr>
+            <a:r>
+              <a:rPr lang="en-US" sz="1100" b="1" dirty="0">
+                <a:solidFill>
+                  <a:srgbClr val="2D3463"/>
+                </a:solidFill>
+                <a:latin typeface="Calibri" pitchFamily="34" charset="0"/>
+                <a:ea typeface="Calibri" pitchFamily="34" charset="-122"/>
+                <a:cs typeface="Calibri" pitchFamily="34" charset="-120"/>
+              </a:rPr>
+              <a:t>Formato do Protocolo Único</a:t>
+            </a:r>
+            <a:endParaRPr lang="en-US" sz="1100" dirty="0"/>
+          </a:p>
+        </p:txBody>
+      </p:sp>
+      <p:sp>
+        <p:nvSpPr>
+          <p:cNvPr id="51" name="Shape 49"/>
+          <p:cNvSpPr/>
+          <p:nvPr/>
+        </p:nvSpPr>
+        <p:spPr>
+          <a:xfrm>
+            <a:off x="731520" y="4343400"/>
+            <a:ext cx="512064" cy="420624"/>
+          </a:xfrm>
+          <a:prstGeom prst="rect">
+            <a:avLst/>
+          </a:prstGeom>
+          <a:solidFill>
+            <a:srgbClr val="EEF0FB"/>
+          </a:solidFill>
+          <a:ln w="12700">
+            <a:solidFill>
+              <a:srgbClr val="C5CCE8"/>
+            </a:solidFill>
+            <a:prstDash val="solid"/>
+          </a:ln>
+        </p:spPr>
+      </p:sp>
+      <p:sp>
+        <p:nvSpPr>
+          <p:cNvPr id="52" name="Text 50"/>
+          <p:cNvSpPr/>
+          <p:nvPr/>
+        </p:nvSpPr>
+        <p:spPr>
+          <a:xfrm>
+            <a:off x="731520" y="4343400"/>
+            <a:ext cx="512064" cy="237744"/>
+          </a:xfrm>
+          <a:prstGeom prst="rect">
+            <a:avLst/>
+          </a:prstGeom>
+          <a:noFill/>
+          <a:ln/>
+        </p:spPr>
+        <p:txBody>
+          <a:bodyPr wrap="square" lIns="0" tIns="0" rIns="0" bIns="0" rtlCol="0" anchor="ctr"/>
+          <a:lstStyle/>
+          <a:p>
+            <a:pPr marL="0" indent="0" algn="ctr">
+              <a:buNone/>
+            </a:pPr>
+            <a:r>
+              <a:rPr lang="en-US" sz="1100" b="1" dirty="0">
+                <a:solidFill>
+                  <a:srgbClr val="4F5DA3"/>
+                </a:solidFill>
+                <a:latin typeface="Consolas" pitchFamily="34" charset="0"/>
+                <a:ea typeface="Consolas" pitchFamily="34" charset="-122"/>
+                <a:cs typeface="Consolas" pitchFamily="34" charset="-120"/>
+              </a:rPr>
+              <a:t>CH</a:t>
+            </a:r>
+            <a:endParaRPr lang="en-US" sz="1100" dirty="0"/>
+          </a:p>
+        </p:txBody>
+      </p:sp>
+      <p:sp>
+        <p:nvSpPr>
+          <p:cNvPr id="53" name="Text 51"/>
+          <p:cNvSpPr/>
+          <p:nvPr/>
+        </p:nvSpPr>
+        <p:spPr>
+          <a:xfrm>
+            <a:off x="731520" y="4581144"/>
+            <a:ext cx="512064" cy="182880"/>
+          </a:xfrm>
+          <a:prstGeom prst="rect">
+            <a:avLst/>
+          </a:prstGeom>
+          <a:noFill/>
+          <a:ln/>
+        </p:spPr>
+        <p:txBody>
+          <a:bodyPr wrap="square" lIns="0" tIns="0" rIns="0" bIns="0" rtlCol="0" anchor="ctr"/>
+          <a:lstStyle/>
+          <a:p>
+            <a:pPr marL="0" indent="0" algn="ctr">
+              <a:buNone/>
+            </a:pPr>
+            <a:r>
+              <a:rPr lang="en-US" sz="750" dirty="0">
+                <a:solidFill>
+                  <a:srgbClr val="6B7280"/>
+                </a:solidFill>
+                <a:latin typeface="Calibri" pitchFamily="34" charset="0"/>
+                <a:ea typeface="Calibri" pitchFamily="34" charset="-122"/>
+                <a:cs typeface="Calibri" pitchFamily="34" charset="-120"/>
+              </a:rPr>
+              <a:t>Prefixo fixo</a:t>
+            </a:r>
+            <a:endParaRPr lang="en-US" sz="750" dirty="0"/>
+          </a:p>
+        </p:txBody>
+      </p:sp>
+      <p:sp>
+        <p:nvSpPr>
+          <p:cNvPr id="54" name="Shape 52"/>
+          <p:cNvSpPr/>
+          <p:nvPr/>
+        </p:nvSpPr>
+        <p:spPr>
+          <a:xfrm>
+            <a:off x="1335024" y="4343400"/>
+            <a:ext cx="585216" cy="420624"/>
+          </a:xfrm>
+          <a:prstGeom prst="rect">
+            <a:avLst/>
+          </a:prstGeom>
+          <a:solidFill>
+            <a:srgbClr val="EEF0FB"/>
+          </a:solidFill>
+          <a:ln w="12700">
+            <a:solidFill>
+              <a:srgbClr val="C5CCE8"/>
+            </a:solidFill>
+            <a:prstDash val="solid"/>
+          </a:ln>
+        </p:spPr>
+      </p:sp>
+      <p:sp>
+        <p:nvSpPr>
+          <p:cNvPr id="55" name="Text 53"/>
+          <p:cNvSpPr/>
+          <p:nvPr/>
+        </p:nvSpPr>
+        <p:spPr>
+          <a:xfrm>
+            <a:off x="1335024" y="4343400"/>
+            <a:ext cx="585216" cy="237744"/>
+          </a:xfrm>
+          <a:prstGeom prst="rect">
+            <a:avLst/>
+          </a:prstGeom>
+          <a:noFill/>
+          <a:ln/>
+        </p:spPr>
+        <p:txBody>
+          <a:bodyPr wrap="square" lIns="0" tIns="0" rIns="0" bIns="0" rtlCol="0" anchor="ctr"/>
+          <a:lstStyle/>
+          <a:p>
+            <a:pPr marL="0" indent="0" algn="ctr">
+              <a:buNone/>
+            </a:pPr>
+            <a:r>
+              <a:rPr lang="en-US" sz="1100" b="1" dirty="0">
+                <a:solidFill>
+                  <a:srgbClr val="4F5DA3"/>
+                </a:solidFill>
+                <a:latin typeface="Consolas" pitchFamily="34" charset="0"/>
+                <a:ea typeface="Consolas" pitchFamily="34" charset="-122"/>
+                <a:cs typeface="Consolas" pitchFamily="34" charset="-120"/>
+              </a:rPr>
+              <a:t>2026</a:t>
+            </a:r>
+            <a:endParaRPr lang="en-US" sz="1100" dirty="0"/>
+          </a:p>
+        </p:txBody>
+      </p:sp>
+      <p:sp>
+        <p:nvSpPr>
+          <p:cNvPr id="56" name="Text 54"/>
+          <p:cNvSpPr/>
+          <p:nvPr/>
+        </p:nvSpPr>
+        <p:spPr>
+          <a:xfrm>
+            <a:off x="1335024" y="4581144"/>
+            <a:ext cx="585216" cy="182880"/>
+          </a:xfrm>
+          <a:prstGeom prst="rect">
+            <a:avLst/>
+          </a:prstGeom>
+          <a:noFill/>
+          <a:ln/>
+        </p:spPr>
+        <p:txBody>
+          <a:bodyPr wrap="square" lIns="0" tIns="0" rIns="0" bIns="0" rtlCol="0" anchor="ctr"/>
+          <a:lstStyle/>
+          <a:p>
+            <a:pPr marL="0" indent="0" algn="ctr">
+              <a:buNone/>
+            </a:pPr>
+            <a:r>
+              <a:rPr lang="en-US" sz="750" dirty="0">
+                <a:solidFill>
+                  <a:srgbClr val="6B7280"/>
+                </a:solidFill>
+                <a:latin typeface="Calibri" pitchFamily="34" charset="0"/>
+                <a:ea typeface="Calibri" pitchFamily="34" charset="-122"/>
+                <a:cs typeface="Calibri" pitchFamily="34" charset="-120"/>
+              </a:rPr>
+              <a:t>Ano</a:t>
+            </a:r>
+            <a:endParaRPr lang="en-US" sz="750" dirty="0"/>
+          </a:p>
+        </p:txBody>
+      </p:sp>
+      <p:sp>
+        <p:nvSpPr>
+          <p:cNvPr id="57" name="Shape 55"/>
+          <p:cNvSpPr/>
+          <p:nvPr/>
+        </p:nvSpPr>
+        <p:spPr>
+          <a:xfrm>
+            <a:off x="2011680" y="4343400"/>
+            <a:ext cx="438912" cy="420624"/>
+          </a:xfrm>
+          <a:prstGeom prst="rect">
+            <a:avLst/>
+          </a:prstGeom>
+          <a:solidFill>
+            <a:srgbClr val="EEF0FB"/>
+          </a:solidFill>
+          <a:ln w="12700">
+            <a:solidFill>
+              <a:srgbClr val="C5CCE8"/>
+            </a:solidFill>
+            <a:prstDash val="solid"/>
+          </a:ln>
+        </p:spPr>
+      </p:sp>
+      <p:sp>
+        <p:nvSpPr>
+          <p:cNvPr id="58" name="Text 56"/>
+          <p:cNvSpPr/>
+          <p:nvPr/>
+        </p:nvSpPr>
+        <p:spPr>
+          <a:xfrm>
+            <a:off x="2011680" y="4343400"/>
+            <a:ext cx="438912" cy="237744"/>
+          </a:xfrm>
+          <a:prstGeom prst="rect">
+            <a:avLst/>
+          </a:prstGeom>
+          <a:noFill/>
+          <a:ln/>
+        </p:spPr>
+        <p:txBody>
+          <a:bodyPr wrap="square" lIns="0" tIns="0" rIns="0" bIns="0" rtlCol="0" anchor="ctr"/>
+          <a:lstStyle/>
+          <a:p>
+            <a:pPr marL="0" indent="0" algn="ctr">
+              <a:buNone/>
+            </a:pPr>
+            <a:r>
+              <a:rPr lang="en-US" sz="1100" b="1" dirty="0">
+                <a:solidFill>
+                  <a:srgbClr val="4F5DA3"/>
+                </a:solidFill>
+                <a:latin typeface="Consolas" pitchFamily="34" charset="0"/>
+                <a:ea typeface="Consolas" pitchFamily="34" charset="-122"/>
+                <a:cs typeface="Consolas" pitchFamily="34" charset="-120"/>
+              </a:rPr>
+              <a:t>02</a:t>
+            </a:r>
+            <a:endParaRPr lang="en-US" sz="1100" dirty="0"/>
+          </a:p>
+        </p:txBody>
+      </p:sp>
+      <p:sp>
+        <p:nvSpPr>
+          <p:cNvPr id="59" name="Text 57"/>
+          <p:cNvSpPr/>
+          <p:nvPr/>
+        </p:nvSpPr>
+        <p:spPr>
+          <a:xfrm>
+            <a:off x="2011680" y="4581144"/>
+            <a:ext cx="438912" cy="182880"/>
+          </a:xfrm>
+          <a:prstGeom prst="rect">
+            <a:avLst/>
+          </a:prstGeom>
+          <a:noFill/>
+          <a:ln/>
+        </p:spPr>
+        <p:txBody>
+          <a:bodyPr wrap="square" lIns="0" tIns="0" rIns="0" bIns="0" rtlCol="0" anchor="ctr"/>
+          <a:lstStyle/>
+          <a:p>
+            <a:pPr marL="0" indent="0" algn="ctr">
+              <a:buNone/>
+            </a:pPr>
+            <a:r>
+              <a:rPr lang="en-US" sz="750" dirty="0">
+                <a:solidFill>
+                  <a:srgbClr val="6B7280"/>
+                </a:solidFill>
+                <a:latin typeface="Calibri" pitchFamily="34" charset="0"/>
+                <a:ea typeface="Calibri" pitchFamily="34" charset="-122"/>
+                <a:cs typeface="Calibri" pitchFamily="34" charset="-120"/>
+              </a:rPr>
+              <a:t>Mês</a:t>
+            </a:r>
+            <a:endParaRPr lang="en-US" sz="750" dirty="0"/>
+          </a:p>
+        </p:txBody>
+      </p:sp>
+      <p:sp>
+        <p:nvSpPr>
+          <p:cNvPr id="60" name="Shape 58"/>
+          <p:cNvSpPr/>
+          <p:nvPr/>
+        </p:nvSpPr>
+        <p:spPr>
+          <a:xfrm>
+            <a:off x="2542032" y="4343400"/>
+            <a:ext cx="438912" cy="420624"/>
+          </a:xfrm>
+          <a:prstGeom prst="rect">
+            <a:avLst/>
+          </a:prstGeom>
+          <a:solidFill>
+            <a:srgbClr val="EEF0FB"/>
+          </a:solidFill>
+          <a:ln w="12700">
+            <a:solidFill>
+              <a:srgbClr val="C5CCE8"/>
+            </a:solidFill>
+            <a:prstDash val="solid"/>
+          </a:ln>
+        </p:spPr>
+      </p:sp>
+      <p:sp>
+        <p:nvSpPr>
+          <p:cNvPr id="61" name="Text 59"/>
+          <p:cNvSpPr/>
+          <p:nvPr/>
+        </p:nvSpPr>
+        <p:spPr>
+          <a:xfrm>
+            <a:off x="2542032" y="4343400"/>
+            <a:ext cx="438912" cy="237744"/>
+          </a:xfrm>
+          <a:prstGeom prst="rect">
+            <a:avLst/>
+          </a:prstGeom>
+          <a:noFill/>
+          <a:ln/>
+        </p:spPr>
+        <p:txBody>
+          <a:bodyPr wrap="square" lIns="0" tIns="0" rIns="0" bIns="0" rtlCol="0" anchor="ctr"/>
+          <a:lstStyle/>
+          <a:p>
+            <a:pPr marL="0" indent="0" algn="ctr">
+              <a:buNone/>
+            </a:pPr>
+            <a:r>
+              <a:rPr lang="en-US" sz="1100" b="1" dirty="0">
+                <a:solidFill>
+                  <a:srgbClr val="4F5DA3"/>
+                </a:solidFill>
+                <a:latin typeface="Consolas" pitchFamily="34" charset="0"/>
+                <a:ea typeface="Consolas" pitchFamily="34" charset="-122"/>
+                <a:cs typeface="Consolas" pitchFamily="34" charset="-120"/>
+              </a:rPr>
+              <a:t>24</a:t>
+            </a:r>
+            <a:endParaRPr lang="en-US" sz="1100" dirty="0"/>
+          </a:p>
+        </p:txBody>
+      </p:sp>
+      <p:sp>
+        <p:nvSpPr>
+          <p:cNvPr id="62" name="Text 60"/>
+          <p:cNvSpPr/>
+          <p:nvPr/>
+        </p:nvSpPr>
+        <p:spPr>
+          <a:xfrm>
+            <a:off x="2542032" y="4581144"/>
+            <a:ext cx="438912" cy="182880"/>
+          </a:xfrm>
+          <a:prstGeom prst="rect">
+            <a:avLst/>
+          </a:prstGeom>
+          <a:noFill/>
+          <a:ln/>
+        </p:spPr>
+        <p:txBody>
+          <a:bodyPr wrap="square" lIns="0" tIns="0" rIns="0" bIns="0" rtlCol="0" anchor="ctr"/>
+          <a:lstStyle/>
+          <a:p>
+            <a:pPr marL="0" indent="0" algn="ctr">
+              <a:buNone/>
+            </a:pPr>
+            <a:r>
+              <a:rPr lang="en-US" sz="750" dirty="0">
+                <a:solidFill>
+                  <a:srgbClr val="6B7280"/>
+                </a:solidFill>
+                <a:latin typeface="Calibri" pitchFamily="34" charset="0"/>
+                <a:ea typeface="Calibri" pitchFamily="34" charset="-122"/>
+                <a:cs typeface="Calibri" pitchFamily="34" charset="-120"/>
+              </a:rPr>
+              <a:t>Dia</a:t>
+            </a:r>
+            <a:endParaRPr lang="en-US" sz="750" dirty="0"/>
+          </a:p>
+        </p:txBody>
+      </p:sp>
+      <p:sp>
+        <p:nvSpPr>
+          <p:cNvPr id="63" name="Shape 61"/>
+          <p:cNvSpPr/>
+          <p:nvPr/>
+        </p:nvSpPr>
+        <p:spPr>
+          <a:xfrm>
+            <a:off x="3072384" y="4343400"/>
+            <a:ext cx="237744" cy="420624"/>
+          </a:xfrm>
+          <a:prstGeom prst="rect">
+            <a:avLst/>
+          </a:prstGeom>
+          <a:solidFill>
+            <a:srgbClr val="FFFFFF"/>
+          </a:solidFill>
+          <a:ln w="12700">
+            <a:solidFill>
+              <a:srgbClr val="FFFFFF"/>
+            </a:solidFill>
+            <a:prstDash val="solid"/>
+          </a:ln>
+        </p:spPr>
+      </p:sp>
+      <p:sp>
+        <p:nvSpPr>
+          <p:cNvPr id="64" name="Text 62"/>
+          <p:cNvSpPr/>
+          <p:nvPr/>
+        </p:nvSpPr>
+        <p:spPr>
+          <a:xfrm>
+            <a:off x="3072384" y="4343400"/>
+            <a:ext cx="237744" cy="237744"/>
+          </a:xfrm>
+          <a:prstGeom prst="rect">
+            <a:avLst/>
+          </a:prstGeom>
+          <a:noFill/>
+          <a:ln/>
+        </p:spPr>
+        <p:txBody>
+          <a:bodyPr wrap="square" lIns="0" tIns="0" rIns="0" bIns="0" rtlCol="0" anchor="ctr"/>
+          <a:lstStyle/>
+          <a:p>
+            <a:pPr marL="0" indent="0" algn="ctr">
+              <a:buNone/>
+            </a:pPr>
+            <a:r>
+              <a:rPr lang="en-US" sz="1100" b="1" dirty="0">
+                <a:solidFill>
+                  <a:srgbClr val="4F5DA3"/>
+                </a:solidFill>
+                <a:latin typeface="Consolas" pitchFamily="34" charset="0"/>
+                <a:ea typeface="Consolas" pitchFamily="34" charset="-122"/>
+                <a:cs typeface="Consolas" pitchFamily="34" charset="-120"/>
+              </a:rPr>
+              <a:t>–</a:t>
+            </a:r>
+            <a:endParaRPr lang="en-US" sz="1100" dirty="0"/>
+          </a:p>
+        </p:txBody>
+      </p:sp>
+      <p:sp>
+        <p:nvSpPr>
+          <p:cNvPr id="65" name="Shape 63"/>
+          <p:cNvSpPr/>
+          <p:nvPr/>
+        </p:nvSpPr>
+        <p:spPr>
+          <a:xfrm>
+            <a:off x="3401568" y="4343400"/>
+            <a:ext cx="950976" cy="420624"/>
+          </a:xfrm>
+          <a:prstGeom prst="rect">
+            <a:avLst/>
+          </a:prstGeom>
+          <a:solidFill>
+            <a:srgbClr val="EEF0FB"/>
+          </a:solidFill>
+          <a:ln w="12700">
+            <a:solidFill>
+              <a:srgbClr val="C5CCE8"/>
+            </a:solidFill>
+            <a:prstDash val="solid"/>
+          </a:ln>
+        </p:spPr>
+      </p:sp>
+      <p:sp>
+        <p:nvSpPr>
+          <p:cNvPr id="66" name="Text 64"/>
+          <p:cNvSpPr/>
+          <p:nvPr/>
+        </p:nvSpPr>
+        <p:spPr>
+          <a:xfrm>
+            <a:off x="3401568" y="4343400"/>
+            <a:ext cx="950976" cy="237744"/>
+          </a:xfrm>
+          <a:prstGeom prst="rect">
+            <a:avLst/>
+          </a:prstGeom>
+          <a:noFill/>
+          <a:ln/>
+        </p:spPr>
+        <p:txBody>
+          <a:bodyPr wrap="square" lIns="0" tIns="0" rIns="0" bIns="0" rtlCol="0" anchor="ctr"/>
+          <a:lstStyle/>
+          <a:p>
+            <a:pPr marL="0" indent="0" algn="ctr">
+              <a:buNone/>
+            </a:pPr>
+            <a:r>
+              <a:rPr lang="en-US" sz="1000" b="1" dirty="0">
+                <a:solidFill>
+                  <a:srgbClr val="4F5DA3"/>
+                </a:solidFill>
+                <a:latin typeface="Consolas" pitchFamily="34" charset="0"/>
+                <a:ea typeface="Consolas" pitchFamily="34" charset="-122"/>
+                <a:cs typeface="Consolas" pitchFamily="34" charset="-120"/>
+              </a:rPr>
+              <a:t>96E29B</a:t>
+            </a:r>
+            <a:endParaRPr lang="en-US" sz="1000" dirty="0"/>
+          </a:p>
+        </p:txBody>
+      </p:sp>
+      <p:sp>
+        <p:nvSpPr>
+          <p:cNvPr id="67" name="Text 65"/>
+          <p:cNvSpPr/>
+          <p:nvPr/>
+        </p:nvSpPr>
+        <p:spPr>
+          <a:xfrm>
+            <a:off x="3401568" y="4581144"/>
+            <a:ext cx="950976" cy="182880"/>
+          </a:xfrm>
+          <a:prstGeom prst="rect">
+            <a:avLst/>
+          </a:prstGeom>
+          <a:noFill/>
+          <a:ln/>
+        </p:spPr>
+        <p:txBody>
+          <a:bodyPr wrap="square" lIns="0" tIns="0" rIns="0" bIns="0" rtlCol="0" anchor="ctr"/>
+          <a:lstStyle/>
+          <a:p>
+            <a:pPr marL="0" indent="0" algn="ctr">
+              <a:buNone/>
+            </a:pPr>
+            <a:r>
+              <a:rPr lang="en-US" sz="750" dirty="0">
+                <a:solidFill>
+                  <a:srgbClr val="6B7280"/>
+                </a:solidFill>
+                <a:latin typeface="Calibri" pitchFamily="34" charset="0"/>
+                <a:ea typeface="Calibri" pitchFamily="34" charset="-122"/>
+                <a:cs typeface="Calibri" pitchFamily="34" charset="-120"/>
+              </a:rPr>
+              <a:t>HEX aleatório</a:t>
+            </a:r>
+            <a:endParaRPr lang="en-US" sz="750" dirty="0"/>
+          </a:p>
+        </p:txBody>
+      </p:sp>
+      <p:sp>
+        <p:nvSpPr>
+          <p:cNvPr id="68" name="Text 66"/>
+          <p:cNvSpPr/>
+          <p:nvPr/>
+        </p:nvSpPr>
+        <p:spPr>
+          <a:xfrm>
+            <a:off x="4626864" y="4407408"/>
+            <a:ext cx="4242816" cy="292608"/>
+          </a:xfrm>
+          <a:prstGeom prst="rect">
+            <a:avLst/>
+          </a:prstGeom>
+          <a:noFill/>
+          <a:ln/>
+        </p:spPr>
+        <p:txBody>
+          <a:bodyPr wrap="square" lIns="0" tIns="0" rIns="0" bIns="0" rtlCol="0" anchor="ctr"/>
+          <a:lstStyle/>
+          <a:p>
+            <a:pPr marL="0" indent="0">
+              <a:buNone/>
+            </a:pPr>
+            <a:r>
+              <a:rPr lang="en-US" sz="850" dirty="0">
+                <a:solidFill>
+                  <a:srgbClr val="6B7280"/>
+                </a:solidFill>
+                <a:latin typeface="Calibri" pitchFamily="34" charset="0"/>
+                <a:ea typeface="Calibri" pitchFamily="34" charset="-122"/>
+                <a:cs typeface="Calibri" pitchFamily="34" charset="-120"/>
+              </a:rPr>
+              <a:t>= Gerado via: 'CH' + date('Ymd') + '-' + strtoupper(substr(md5(uniqid()),0,6))</a:t>
+            </a:r>
+            <a:endParaRPr lang="en-US" sz="850" dirty="0"/>
           </a:p>
         </p:txBody>
       </p:sp>
@@ -2596,6 +4387,475 @@
 
 <file path=ppt/slides/slide3.xml><?xml version="1.0" encoding="utf-8"?>
 <p:sld xmlns:a="http://schemas.openxmlformats.org/drawingml/2006/main" xmlns:r="http://schemas.openxmlformats.org/officeDocument/2006/relationships" xmlns:p="http://schemas.openxmlformats.org/presentationml/2006/main">
+  <p:cSld>
+    <p:bg>
+      <p:bgPr>
+        <a:solidFill>
+          <a:srgbClr val="F8F9FC"/>
+        </a:solidFill>
+        <a:effectLst/>
+      </p:bgPr>
+    </p:bg>
+    <p:spTree>
+      <p:nvGrpSpPr>
+        <p:cNvPr id="1" name=""/>
+        <p:cNvGrpSpPr/>
+        <p:nvPr/>
+      </p:nvGrpSpPr>
+      <p:grpSpPr>
+        <a:xfrm>
+          <a:off x="0" y="0"/>
+          <a:ext cx="0" cy="0"/>
+          <a:chOff x="0" y="0"/>
+          <a:chExt cx="0" cy="0"/>
+        </a:xfrm>
+      </p:grpSpPr>
+      <p:sp>
+        <p:nvSpPr>
+          <p:cNvPr id="2" name="Shape 0"/>
+          <p:cNvSpPr/>
+          <p:nvPr/>
+        </p:nvSpPr>
+        <p:spPr>
+          <a:xfrm>
+            <a:off x="0" y="-9615"/>
+            <a:ext cx="9144000" cy="685800"/>
+          </a:xfrm>
+          <a:prstGeom prst="rect">
+            <a:avLst/>
+          </a:prstGeom>
+          <a:solidFill>
+            <a:srgbClr val="2D3463"/>
+          </a:solidFill>
+          <a:ln w="12700">
+            <a:solidFill>
+              <a:srgbClr val="2D3463"/>
+            </a:solidFill>
+            <a:prstDash val="solid"/>
+          </a:ln>
+        </p:spPr>
+      </p:sp>
+      <p:sp>
+        <p:nvSpPr>
+          <p:cNvPr id="3" name="Text 1"/>
+          <p:cNvSpPr/>
+          <p:nvPr/>
+        </p:nvSpPr>
+        <p:spPr>
+          <a:xfrm>
+            <a:off x="320040" y="109493"/>
+            <a:ext cx="6400800" cy="685800"/>
+          </a:xfrm>
+          <a:prstGeom prst="rect">
+            <a:avLst/>
+          </a:prstGeom>
+          <a:noFill/>
+          <a:ln/>
+        </p:spPr>
+        <p:txBody>
+          <a:bodyPr wrap="square" lIns="0" tIns="0" rIns="0" bIns="0" rtlCol="0" anchor="ctr"/>
+          <a:lstStyle/>
+          <a:p>
+            <a:r>
+              <a:rPr lang="pt-BR" sz="1600" b="1" dirty="0">
+                <a:solidFill>
+                  <a:schemeClr val="bg1"/>
+                </a:solidFill>
+              </a:rPr>
+              <a:t>Justificativa Técnica das Tecnologias Escolhidas</a:t>
+            </a:r>
+          </a:p>
+          <a:p>
+            <a:pPr marL="0" indent="0">
+              <a:buNone/>
+            </a:pPr>
+            <a:endParaRPr lang="en-US" sz="1600" dirty="0"/>
+          </a:p>
+        </p:txBody>
+      </p:sp>
+      <p:sp>
+        <p:nvSpPr>
+          <p:cNvPr id="4" name="Text 2"/>
+          <p:cNvSpPr/>
+          <p:nvPr/>
+        </p:nvSpPr>
+        <p:spPr>
+          <a:xfrm>
+            <a:off x="6400800" y="0"/>
+            <a:ext cx="2468880" cy="685800"/>
+          </a:xfrm>
+          <a:prstGeom prst="rect">
+            <a:avLst/>
+          </a:prstGeom>
+          <a:noFill/>
+          <a:ln/>
+        </p:spPr>
+        <p:txBody>
+          <a:bodyPr wrap="square" lIns="0" tIns="0" rIns="0" bIns="0" rtlCol="0" anchor="ctr"/>
+          <a:lstStyle/>
+          <a:p>
+            <a:pPr marL="0" indent="0" algn="r">
+              <a:buNone/>
+            </a:pPr>
+            <a:r>
+              <a:rPr lang="en-US" sz="1100" dirty="0">
+                <a:solidFill>
+                  <a:srgbClr val="CADCFC"/>
+                </a:solidFill>
+                <a:latin typeface="Calibri" pitchFamily="34" charset="0"/>
+                <a:ea typeface="Calibri" pitchFamily="34" charset="-122"/>
+                <a:cs typeface="Calibri" pitchFamily="34" charset="-120"/>
+              </a:rPr>
+              <a:t>AJAX: /ajax/abertura/listar.php</a:t>
+            </a:r>
+            <a:endParaRPr lang="en-US" sz="1100" dirty="0"/>
+          </a:p>
+        </p:txBody>
+      </p:sp>
+      <p:sp>
+        <p:nvSpPr>
+          <p:cNvPr id="5" name="Shape 3"/>
+          <p:cNvSpPr/>
+          <p:nvPr/>
+        </p:nvSpPr>
+        <p:spPr>
+          <a:xfrm>
+            <a:off x="320040" y="1042416"/>
+            <a:ext cx="8503920" cy="3922874"/>
+          </a:xfrm>
+          <a:prstGeom prst="rect">
+            <a:avLst/>
+          </a:prstGeom>
+          <a:solidFill>
+            <a:srgbClr val="FFFFFF"/>
+          </a:solidFill>
+          <a:ln w="12700">
+            <a:solidFill>
+              <a:srgbClr val="E2E5EF"/>
+            </a:solidFill>
+            <a:prstDash val="solid"/>
+          </a:ln>
+        </p:spPr>
+      </p:sp>
+      <p:sp>
+        <p:nvSpPr>
+          <p:cNvPr id="8" name="Text 6"/>
+          <p:cNvSpPr/>
+          <p:nvPr/>
+        </p:nvSpPr>
+        <p:spPr>
+          <a:xfrm>
+            <a:off x="5038344" y="914400"/>
+            <a:ext cx="1170432" cy="256032"/>
+          </a:xfrm>
+          <a:prstGeom prst="rect">
+            <a:avLst/>
+          </a:prstGeom>
+          <a:noFill/>
+          <a:ln/>
+        </p:spPr>
+        <p:txBody>
+          <a:bodyPr wrap="square" lIns="0" tIns="0" rIns="0" bIns="0" rtlCol="0" anchor="ctr"/>
+          <a:lstStyle/>
+          <a:p>
+            <a:pPr marL="0" indent="0" algn="ctr">
+              <a:buNone/>
+            </a:pPr>
+            <a:r>
+              <a:rPr lang="en-US" sz="850" b="1" dirty="0">
+                <a:solidFill>
+                  <a:srgbClr val="FFFFFF"/>
+                </a:solidFill>
+                <a:latin typeface="Calibri" pitchFamily="34" charset="0"/>
+                <a:ea typeface="Calibri" pitchFamily="34" charset="-122"/>
+                <a:cs typeface="Calibri" pitchFamily="34" charset="-120"/>
+              </a:rPr>
+              <a:t>+ Novo Chamado</a:t>
+            </a:r>
+            <a:endParaRPr lang="en-US" sz="850" dirty="0"/>
+          </a:p>
+        </p:txBody>
+      </p:sp>
+      <p:sp>
+        <p:nvSpPr>
+          <p:cNvPr id="6" name="CaixaDeTexto 5"/>
+          <p:cNvSpPr txBox="1"/>
+          <p:nvPr/>
+        </p:nvSpPr>
+        <p:spPr>
+          <a:xfrm>
+            <a:off x="589936" y="1337187"/>
+            <a:ext cx="8133650" cy="3416320"/>
+          </a:xfrm>
+          <a:prstGeom prst="rect">
+            <a:avLst/>
+          </a:prstGeom>
+          <a:noFill/>
+        </p:spPr>
+        <p:txBody>
+          <a:bodyPr wrap="square" rtlCol="0">
+            <a:spAutoFit/>
+          </a:bodyPr>
+          <a:lstStyle/>
+          <a:p>
+            <a:r>
+              <a:rPr lang="pt-BR" sz="1200" b="1" dirty="0" smtClean="0"/>
+              <a:t>PHP </a:t>
+            </a:r>
+            <a:r>
+              <a:rPr lang="pt-BR" sz="1200" b="1" dirty="0"/>
+              <a:t>(Back-</a:t>
+            </a:r>
+            <a:r>
+              <a:rPr lang="pt-BR" sz="1200" b="1" dirty="0" err="1"/>
+              <a:t>end</a:t>
+            </a:r>
+            <a:r>
+              <a:rPr lang="pt-BR" sz="1200" b="1" dirty="0"/>
+              <a:t>)</a:t>
+            </a:r>
+          </a:p>
+          <a:p>
+            <a:r>
+              <a:rPr lang="pt-BR" sz="1200" dirty="0"/>
+              <a:t>O PHP foi escolhido por ser uma linguagem madura, amplamente suportada em hospedagens compartilhadas e servidores Linux, o que garante facilidade de </a:t>
+            </a:r>
+            <a:r>
+              <a:rPr lang="pt-BR" sz="1200" dirty="0" err="1"/>
+              <a:t>deploy</a:t>
+            </a:r>
+            <a:r>
+              <a:rPr lang="pt-BR" sz="1200" dirty="0"/>
+              <a:t> sem dependências complexas. A versão utilizada (8.2) oferece recursos modernos como </a:t>
+            </a:r>
+            <a:r>
+              <a:rPr lang="pt-BR" sz="1200" dirty="0" err="1"/>
+              <a:t>tipagem</a:t>
+            </a:r>
+            <a:r>
+              <a:rPr lang="pt-BR" sz="1200" dirty="0"/>
+              <a:t> forte, </a:t>
+            </a:r>
+            <a:r>
+              <a:rPr lang="pt-BR" sz="1200" dirty="0" err="1"/>
+              <a:t>enumerations</a:t>
+            </a:r>
+            <a:r>
+              <a:rPr lang="pt-BR" sz="1200" dirty="0"/>
+              <a:t> e match </a:t>
+            </a:r>
+            <a:r>
+              <a:rPr lang="pt-BR" sz="1200" dirty="0" err="1"/>
+              <a:t>expressions</a:t>
+            </a:r>
+            <a:r>
+              <a:rPr lang="pt-BR" sz="1200" dirty="0"/>
+              <a:t>. A conexão com o banco de dados é feita via PDO (PHP Data </a:t>
+            </a:r>
+            <a:r>
+              <a:rPr lang="pt-BR" sz="1200" dirty="0" err="1"/>
+              <a:t>Objects</a:t>
+            </a:r>
+            <a:r>
+              <a:rPr lang="pt-BR" sz="1200" dirty="0"/>
+              <a:t>), que abstrai o banco de dados e protege contra injeção de SQL por meio de </a:t>
+            </a:r>
+            <a:r>
+              <a:rPr lang="pt-BR" sz="1200" dirty="0" err="1"/>
+              <a:t>prepared</a:t>
+            </a:r>
+            <a:r>
+              <a:rPr lang="pt-BR" sz="1200" dirty="0"/>
+              <a:t> </a:t>
+            </a:r>
+            <a:r>
+              <a:rPr lang="pt-BR" sz="1200" dirty="0" err="1"/>
+              <a:t>statements</a:t>
+            </a:r>
+            <a:r>
+              <a:rPr lang="pt-BR" sz="1200" dirty="0"/>
+              <a:t>. A gestão de sessões nativas do PHP, combinada com </a:t>
+            </a:r>
+            <a:r>
+              <a:rPr lang="pt-BR" sz="1200" dirty="0" err="1"/>
+              <a:t>hashing</a:t>
+            </a:r>
+            <a:r>
+              <a:rPr lang="pt-BR" sz="1200" dirty="0"/>
+              <a:t> </a:t>
+            </a:r>
+            <a:r>
+              <a:rPr lang="pt-BR" sz="1200" dirty="0" err="1"/>
+              <a:t>bcrypt</a:t>
+            </a:r>
+            <a:r>
+              <a:rPr lang="pt-BR" sz="1200" dirty="0"/>
+              <a:t> (</a:t>
+            </a:r>
+            <a:r>
+              <a:rPr lang="pt-BR" sz="1200" dirty="0" err="1"/>
+              <a:t>password_hash</a:t>
+            </a:r>
+            <a:r>
+              <a:rPr lang="pt-BR" sz="1200" dirty="0"/>
+              <a:t>), garante autenticação segura.</a:t>
+            </a:r>
+          </a:p>
+          <a:p>
+            <a:endParaRPr lang="pt-BR" sz="1200" b="1" dirty="0" smtClean="0"/>
+          </a:p>
+          <a:p>
+            <a:r>
+              <a:rPr lang="pt-BR" sz="1200" b="1" dirty="0" smtClean="0"/>
+              <a:t>MySQL </a:t>
+            </a:r>
+            <a:r>
+              <a:rPr lang="pt-BR" sz="1200" b="1" dirty="0"/>
+              <a:t>/ </a:t>
+            </a:r>
+            <a:r>
+              <a:rPr lang="pt-BR" sz="1200" b="1" dirty="0" err="1"/>
+              <a:t>MariaDB</a:t>
+            </a:r>
+            <a:r>
+              <a:rPr lang="pt-BR" sz="1200" b="1" dirty="0"/>
+              <a:t> (Banco de Dados)</a:t>
+            </a:r>
+          </a:p>
+          <a:p>
+            <a:r>
+              <a:rPr lang="pt-BR" sz="1200" dirty="0"/>
+              <a:t>O MySQL, utilizado via </a:t>
+            </a:r>
+            <a:r>
+              <a:rPr lang="pt-BR" sz="1200" dirty="0" err="1"/>
+              <a:t>MariaDB</a:t>
+            </a:r>
+            <a:r>
+              <a:rPr lang="pt-BR" sz="1200" dirty="0"/>
+              <a:t> 10.4, é o banco de dados relacional mais popular em ambientes LAMP. O uso de </a:t>
+            </a:r>
+            <a:r>
+              <a:rPr lang="pt-BR" sz="1200" dirty="0" err="1"/>
+              <a:t>InnoDB</a:t>
+            </a:r>
+            <a:r>
+              <a:rPr lang="pt-BR" sz="1200" dirty="0"/>
+              <a:t> como </a:t>
+            </a:r>
+            <a:r>
+              <a:rPr lang="pt-BR" sz="1200" dirty="0" err="1"/>
+              <a:t>engine</a:t>
+            </a:r>
+            <a:r>
+              <a:rPr lang="pt-BR" sz="1200" dirty="0"/>
+              <a:t> garante integridade referencial por meio de chaves estrangeiras (FOREIGN KEY), suporte a transações ACID e </a:t>
+            </a:r>
+            <a:r>
+              <a:rPr lang="pt-BR" sz="1200" dirty="0" err="1"/>
+              <a:t>rollback</a:t>
+            </a:r>
+            <a:r>
+              <a:rPr lang="pt-BR" sz="1200" dirty="0"/>
+              <a:t> em caso de falha. O </a:t>
+            </a:r>
+            <a:r>
+              <a:rPr lang="pt-BR" sz="1200" dirty="0" err="1"/>
+              <a:t>charset</a:t>
+            </a:r>
+            <a:r>
+              <a:rPr lang="pt-BR" sz="1200" dirty="0"/>
+              <a:t> utf8mb4 garante suporte completo a caracteres especiais e </a:t>
+            </a:r>
+            <a:r>
+              <a:rPr lang="pt-BR" sz="1200" dirty="0" err="1"/>
+              <a:t>emojis</a:t>
+            </a:r>
+            <a:r>
+              <a:rPr lang="pt-BR" sz="1200" dirty="0"/>
+              <a:t>.</a:t>
+            </a:r>
+          </a:p>
+          <a:p>
+            <a:endParaRPr lang="pt-BR" sz="1200" b="1" dirty="0" smtClean="0"/>
+          </a:p>
+          <a:p>
+            <a:r>
+              <a:rPr lang="pt-BR" sz="1200" b="1" dirty="0" err="1" smtClean="0"/>
+              <a:t>Bootstrap</a:t>
+            </a:r>
+            <a:r>
+              <a:rPr lang="pt-BR" sz="1200" b="1" dirty="0" smtClean="0"/>
+              <a:t> </a:t>
+            </a:r>
+            <a:r>
+              <a:rPr lang="pt-BR" sz="1200" b="1" dirty="0"/>
+              <a:t>5 (Front-</a:t>
+            </a:r>
+            <a:r>
+              <a:rPr lang="pt-BR" sz="1200" b="1" dirty="0" err="1"/>
+              <a:t>end</a:t>
+            </a:r>
+            <a:r>
+              <a:rPr lang="pt-BR" sz="1200" b="1" dirty="0"/>
+              <a:t>)</a:t>
+            </a:r>
+          </a:p>
+          <a:p>
+            <a:r>
+              <a:rPr lang="pt-BR" sz="1200" dirty="0"/>
+              <a:t>O </a:t>
+            </a:r>
+            <a:r>
+              <a:rPr lang="pt-BR" sz="1200" dirty="0" err="1"/>
+              <a:t>Bootstrap</a:t>
+            </a:r>
+            <a:r>
+              <a:rPr lang="pt-BR" sz="1200" dirty="0"/>
+              <a:t> 5 foi adotado por três razões principais: (1) Sistema de grid responsivo que adapta o layout para dispositivos móveis e desktops sem código CSS adicional; (2) Componentes prontos (modais, tabelas, </a:t>
+            </a:r>
+            <a:r>
+              <a:rPr lang="pt-BR" sz="1200" dirty="0" err="1"/>
+              <a:t>badges</a:t>
+            </a:r>
+            <a:r>
+              <a:rPr lang="pt-BR" sz="1200" dirty="0"/>
+              <a:t>, botões) que aceleram o desenvolvimento e garantem consistência visual; (3) Integração com </a:t>
+            </a:r>
+            <a:r>
+              <a:rPr lang="pt-BR" sz="1200" dirty="0" err="1"/>
+              <a:t>Bootstrap</a:t>
+            </a:r>
+            <a:r>
+              <a:rPr lang="pt-BR" sz="1200" dirty="0"/>
+              <a:t> </a:t>
+            </a:r>
+            <a:r>
+              <a:rPr lang="pt-BR" sz="1200" dirty="0" err="1"/>
+              <a:t>Icons</a:t>
+            </a:r>
+            <a:r>
+              <a:rPr lang="pt-BR" sz="1200" dirty="0"/>
+              <a:t> para ícones vetoriais sem dependência de imagens externas. O uso de variáveis CSS (--cor-primaria e --cor-secundaria) permite que as cores do sistema sejam personalizadas diretamente pelo painel de configurações, sem necessidade de alterar o código.</a:t>
+            </a:r>
+          </a:p>
+        </p:txBody>
+      </p:sp>
+    </p:spTree>
+    <p:extLst>
+      <p:ext uri="{BB962C8B-B14F-4D97-AF65-F5344CB8AC3E}">
+        <p14:creationId xmlns:p14="http://schemas.microsoft.com/office/powerpoint/2010/main" val="1169691341"/>
+      </p:ext>
+    </p:extLst>
+  </p:cSld>
+  <p:clrMapOvr>
+    <a:masterClrMapping/>
+  </p:clrMapOvr>
+</p:sld>
+</file>
+
+<file path=ppt/slides/slide4.xml><?xml version="1.0" encoding="utf-8"?>
+<p:sld xmlns:a="http://schemas.openxmlformats.org/drawingml/2006/main" xmlns:r="http://schemas.openxmlformats.org/officeDocument/2006/relationships" xmlns:p="http://schemas.openxmlformats.org/presentationml/2006/main">
   <p:cSld name="Slide 2">
     <p:bg>
       <p:bgPr>
@@ -3816,7 +6076,7 @@
 </p:sld>
 </file>
 
-<file path=ppt/slides/slide4.xml><?xml version="1.0" encoding="utf-8"?>
+<file path=ppt/slides/slide5.xml><?xml version="1.0" encoding="utf-8"?>
 <p:sld xmlns:a="http://schemas.openxmlformats.org/drawingml/2006/main" xmlns:r="http://schemas.openxmlformats.org/officeDocument/2006/relationships" xmlns:p="http://schemas.openxmlformats.org/presentationml/2006/main">
   <p:cSld name="Slide 3">
     <p:bg>
@@ -6310,7 +8570,7 @@
 </p:sld>
 </file>
 
-<file path=ppt/slides/slide5.xml><?xml version="1.0" encoding="utf-8"?>
+<file path=ppt/slides/slide6.xml><?xml version="1.0" encoding="utf-8"?>
 <p:sld xmlns:a="http://schemas.openxmlformats.org/drawingml/2006/main" xmlns:r="http://schemas.openxmlformats.org/officeDocument/2006/relationships" xmlns:p="http://schemas.openxmlformats.org/presentationml/2006/main">
   <p:cSld name="Slide 4">
     <p:bg>
@@ -8675,7 +10935,7 @@
 </p:sld>
 </file>
 
-<file path=ppt/slides/slide6.xml><?xml version="1.0" encoding="utf-8"?>
+<file path=ppt/slides/slide7.xml><?xml version="1.0" encoding="utf-8"?>
 <p:sld xmlns:a="http://schemas.openxmlformats.org/drawingml/2006/main" xmlns:r="http://schemas.openxmlformats.org/officeDocument/2006/relationships" xmlns:p="http://schemas.openxmlformats.org/presentationml/2006/main">
   <p:cSld name="Slide 5">
     <p:bg>
@@ -10541,7 +12801,7 @@
 </p:sld>
 </file>
 
-<file path=ppt/slides/slide7.xml><?xml version="1.0" encoding="utf-8"?>
+<file path=ppt/slides/slide8.xml><?xml version="1.0" encoding="utf-8"?>
 <p:sld xmlns:a="http://schemas.openxmlformats.org/drawingml/2006/main" xmlns:r="http://schemas.openxmlformats.org/officeDocument/2006/relationships" xmlns:p="http://schemas.openxmlformats.org/presentationml/2006/main">
   <p:cSld name="Slide 6">
     <p:bg>
@@ -12453,7 +14713,7 @@
 </p:sld>
 </file>
 
-<file path=ppt/slides/slide8.xml><?xml version="1.0" encoding="utf-8"?>
+<file path=ppt/slides/slide9.xml><?xml version="1.0" encoding="utf-8"?>
 <p:sld xmlns:a="http://schemas.openxmlformats.org/drawingml/2006/main" xmlns:r="http://schemas.openxmlformats.org/officeDocument/2006/relationships" xmlns:p="http://schemas.openxmlformats.org/presentationml/2006/main">
   <p:cSld name="Slide 7">
     <p:bg>
@@ -14305,1712 +16565,6 @@
                 <a:cs typeface="Calibri" pitchFamily="34" charset="-120"/>
               </a:rPr>
               <a:t>Histórico de backups com data/hora</a:t>
-            </a:r>
-            <a:endParaRPr lang="en-US" sz="850" dirty="0"/>
-          </a:p>
-        </p:txBody>
-      </p:sp>
-    </p:spTree>
-  </p:cSld>
-  <p:clrMapOvr>
-    <a:masterClrMapping/>
-  </p:clrMapOvr>
-</p:sld>
-</file>
-
-<file path=ppt/slides/slide9.xml><?xml version="1.0" encoding="utf-8"?>
-<p:sld xmlns:a="http://schemas.openxmlformats.org/drawingml/2006/main" xmlns:r="http://schemas.openxmlformats.org/officeDocument/2006/relationships" xmlns:p="http://schemas.openxmlformats.org/presentationml/2006/main">
-  <p:cSld name="Slide 8">
-    <p:bg>
-      <p:bgPr>
-        <a:solidFill>
-          <a:srgbClr val="F8F9FC"/>
-        </a:solidFill>
-        <a:effectLst/>
-      </p:bgPr>
-    </p:bg>
-    <p:spTree>
-      <p:nvGrpSpPr>
-        <p:cNvPr id="1" name=""/>
-        <p:cNvGrpSpPr/>
-        <p:nvPr/>
-      </p:nvGrpSpPr>
-      <p:grpSpPr>
-        <a:xfrm>
-          <a:off x="0" y="0"/>
-          <a:ext cx="0" cy="0"/>
-          <a:chOff x="0" y="0"/>
-          <a:chExt cx="0" cy="0"/>
-        </a:xfrm>
-      </p:grpSpPr>
-      <p:sp>
-        <p:nvSpPr>
-          <p:cNvPr id="2" name="Shape 0"/>
-          <p:cNvSpPr/>
-          <p:nvPr/>
-        </p:nvSpPr>
-        <p:spPr>
-          <a:xfrm>
-            <a:off x="0" y="0"/>
-            <a:ext cx="9144000" cy="685800"/>
-          </a:xfrm>
-          <a:prstGeom prst="rect">
-            <a:avLst/>
-          </a:prstGeom>
-          <a:solidFill>
-            <a:srgbClr val="2D3463"/>
-          </a:solidFill>
-          <a:ln w="12700">
-            <a:solidFill>
-              <a:srgbClr val="2D3463"/>
-            </a:solidFill>
-            <a:prstDash val="solid"/>
-          </a:ln>
-        </p:spPr>
-      </p:sp>
-      <p:sp>
-        <p:nvSpPr>
-          <p:cNvPr id="3" name="Text 1"/>
-          <p:cNvSpPr/>
-          <p:nvPr/>
-        </p:nvSpPr>
-        <p:spPr>
-          <a:xfrm>
-            <a:off x="365760" y="0"/>
-            <a:ext cx="8412480" cy="685800"/>
-          </a:xfrm>
-          <a:prstGeom prst="rect">
-            <a:avLst/>
-          </a:prstGeom>
-          <a:noFill/>
-          <a:ln/>
-        </p:spPr>
-        <p:txBody>
-          <a:bodyPr wrap="square" lIns="0" tIns="0" rIns="0" bIns="0" rtlCol="0" anchor="ctr"/>
-          <a:lstStyle/>
-          <a:p>
-            <a:pPr marL="0" indent="0">
-              <a:buNone/>
-            </a:pPr>
-            <a:r>
-              <a:rPr lang="en-US" sz="1600" b="1" dirty="0">
-                <a:solidFill>
-                  <a:srgbClr val="FFFFFF"/>
-                </a:solidFill>
-                <a:latin typeface="Calibri" pitchFamily="34" charset="0"/>
-                <a:ea typeface="Calibri" pitchFamily="34" charset="-122"/>
-                <a:cs typeface="Calibri" pitchFamily="34" charset="-120"/>
-              </a:rPr>
-              <a:t>PALETA DE CORES  &amp;  FLUXO DO CHAMADO</a:t>
-            </a:r>
-            <a:endParaRPr lang="en-US" sz="1600" dirty="0"/>
-          </a:p>
-        </p:txBody>
-      </p:sp>
-      <p:sp>
-        <p:nvSpPr>
-          <p:cNvPr id="4" name="Text 2"/>
-          <p:cNvSpPr/>
-          <p:nvPr/>
-        </p:nvSpPr>
-        <p:spPr>
-          <a:xfrm>
-            <a:off x="365760" y="822960"/>
-            <a:ext cx="8412480" cy="274320"/>
-          </a:xfrm>
-          <a:prstGeom prst="rect">
-            <a:avLst/>
-          </a:prstGeom>
-          <a:noFill/>
-          <a:ln/>
-        </p:spPr>
-        <p:txBody>
-          <a:bodyPr wrap="square" lIns="0" tIns="0" rIns="0" bIns="0" rtlCol="0" anchor="ctr"/>
-          <a:lstStyle/>
-          <a:p>
-            <a:pPr marL="0" indent="0">
-              <a:buNone/>
-            </a:pPr>
-            <a:r>
-              <a:rPr lang="en-US" sz="1100" b="1" dirty="0">
-                <a:solidFill>
-                  <a:srgbClr val="2D3463"/>
-                </a:solidFill>
-                <a:latin typeface="Calibri" pitchFamily="34" charset="0"/>
-                <a:ea typeface="Calibri" pitchFamily="34" charset="-122"/>
-                <a:cs typeface="Calibri" pitchFamily="34" charset="-120"/>
-              </a:rPr>
-              <a:t>Status dos Chamados (tabela chamados_status)</a:t>
-            </a:r>
-            <a:endParaRPr lang="en-US" sz="1100" dirty="0"/>
-          </a:p>
-        </p:txBody>
-      </p:sp>
-      <p:sp>
-        <p:nvSpPr>
-          <p:cNvPr id="5" name="Shape 3"/>
-          <p:cNvSpPr/>
-          <p:nvPr/>
-        </p:nvSpPr>
-        <p:spPr>
-          <a:xfrm>
-            <a:off x="365760" y="1152144"/>
-            <a:ext cx="1353312" cy="457200"/>
-          </a:xfrm>
-          <a:prstGeom prst="rect">
-            <a:avLst/>
-          </a:prstGeom>
-          <a:solidFill>
-            <a:srgbClr val="0D6EFD"/>
-          </a:solidFill>
-          <a:ln w="12700">
-            <a:solidFill>
-              <a:srgbClr val="0D6EFD"/>
-            </a:solidFill>
-            <a:prstDash val="solid"/>
-          </a:ln>
-        </p:spPr>
-      </p:sp>
-      <p:sp>
-        <p:nvSpPr>
-          <p:cNvPr id="6" name="Text 4"/>
-          <p:cNvSpPr/>
-          <p:nvPr/>
-        </p:nvSpPr>
-        <p:spPr>
-          <a:xfrm>
-            <a:off x="365760" y="1152144"/>
-            <a:ext cx="1353312" cy="274320"/>
-          </a:xfrm>
-          <a:prstGeom prst="rect">
-            <a:avLst/>
-          </a:prstGeom>
-          <a:noFill/>
-          <a:ln/>
-        </p:spPr>
-        <p:txBody>
-          <a:bodyPr wrap="square" lIns="0" tIns="0" rIns="0" bIns="0" rtlCol="0" anchor="ctr"/>
-          <a:lstStyle/>
-          <a:p>
-            <a:pPr marL="0" indent="0" algn="ctr">
-              <a:buNone/>
-            </a:pPr>
-            <a:r>
-              <a:rPr lang="en-US" sz="850" b="1" dirty="0">
-                <a:solidFill>
-                  <a:srgbClr val="FFFFFF"/>
-                </a:solidFill>
-                <a:latin typeface="Consolas" pitchFamily="34" charset="0"/>
-                <a:ea typeface="Consolas" pitchFamily="34" charset="-122"/>
-                <a:cs typeface="Consolas" pitchFamily="34" charset="-120"/>
-              </a:rPr>
-              <a:t>#0D6EFD</a:t>
-            </a:r>
-            <a:endParaRPr lang="en-US" sz="850" dirty="0"/>
-          </a:p>
-        </p:txBody>
-      </p:sp>
-      <p:sp>
-        <p:nvSpPr>
-          <p:cNvPr id="7" name="Text 5"/>
-          <p:cNvSpPr/>
-          <p:nvPr/>
-        </p:nvSpPr>
-        <p:spPr>
-          <a:xfrm>
-            <a:off x="365760" y="1426464"/>
-            <a:ext cx="1353312" cy="182880"/>
-          </a:xfrm>
-          <a:prstGeom prst="rect">
-            <a:avLst/>
-          </a:prstGeom>
-          <a:noFill/>
-          <a:ln/>
-        </p:spPr>
-        <p:txBody>
-          <a:bodyPr wrap="square" lIns="0" tIns="0" rIns="0" bIns="0" rtlCol="0" anchor="ctr"/>
-          <a:lstStyle/>
-          <a:p>
-            <a:pPr marL="0" indent="0" algn="ctr">
-              <a:buNone/>
-            </a:pPr>
-            <a:r>
-              <a:rPr lang="en-US" sz="750" dirty="0">
-                <a:solidFill>
-                  <a:srgbClr val="FFFFFF"/>
-                </a:solidFill>
-                <a:latin typeface="Calibri" pitchFamily="34" charset="0"/>
-                <a:ea typeface="Calibri" pitchFamily="34" charset="-122"/>
-                <a:cs typeface="Calibri" pitchFamily="34" charset="-120"/>
-              </a:rPr>
-              <a:t>Aberto</a:t>
-            </a:r>
-            <a:endParaRPr lang="en-US" sz="750" dirty="0"/>
-          </a:p>
-        </p:txBody>
-      </p:sp>
-      <p:sp>
-        <p:nvSpPr>
-          <p:cNvPr id="8" name="Shape 6"/>
-          <p:cNvSpPr/>
-          <p:nvPr/>
-        </p:nvSpPr>
-        <p:spPr>
-          <a:xfrm>
-            <a:off x="1810512" y="1152144"/>
-            <a:ext cx="1353312" cy="457200"/>
-          </a:xfrm>
-          <a:prstGeom prst="rect">
-            <a:avLst/>
-          </a:prstGeom>
-          <a:solidFill>
-            <a:srgbClr val="6F42C1"/>
-          </a:solidFill>
-          <a:ln w="12700">
-            <a:solidFill>
-              <a:srgbClr val="6F42C1"/>
-            </a:solidFill>
-            <a:prstDash val="solid"/>
-          </a:ln>
-        </p:spPr>
-      </p:sp>
-      <p:sp>
-        <p:nvSpPr>
-          <p:cNvPr id="9" name="Text 7"/>
-          <p:cNvSpPr/>
-          <p:nvPr/>
-        </p:nvSpPr>
-        <p:spPr>
-          <a:xfrm>
-            <a:off x="1810512" y="1152144"/>
-            <a:ext cx="1353312" cy="274320"/>
-          </a:xfrm>
-          <a:prstGeom prst="rect">
-            <a:avLst/>
-          </a:prstGeom>
-          <a:noFill/>
-          <a:ln/>
-        </p:spPr>
-        <p:txBody>
-          <a:bodyPr wrap="square" lIns="0" tIns="0" rIns="0" bIns="0" rtlCol="0" anchor="ctr"/>
-          <a:lstStyle/>
-          <a:p>
-            <a:pPr marL="0" indent="0" algn="ctr">
-              <a:buNone/>
-            </a:pPr>
-            <a:r>
-              <a:rPr lang="en-US" sz="850" b="1" dirty="0">
-                <a:solidFill>
-                  <a:srgbClr val="FFFFFF"/>
-                </a:solidFill>
-                <a:latin typeface="Consolas" pitchFamily="34" charset="0"/>
-                <a:ea typeface="Consolas" pitchFamily="34" charset="-122"/>
-                <a:cs typeface="Consolas" pitchFamily="34" charset="-120"/>
-              </a:rPr>
-              <a:t>#6F42C1</a:t>
-            </a:r>
-            <a:endParaRPr lang="en-US" sz="850" dirty="0"/>
-          </a:p>
-        </p:txBody>
-      </p:sp>
-      <p:sp>
-        <p:nvSpPr>
-          <p:cNvPr id="10" name="Text 8"/>
-          <p:cNvSpPr/>
-          <p:nvPr/>
-        </p:nvSpPr>
-        <p:spPr>
-          <a:xfrm>
-            <a:off x="1810512" y="1426464"/>
-            <a:ext cx="1353312" cy="182880"/>
-          </a:xfrm>
-          <a:prstGeom prst="rect">
-            <a:avLst/>
-          </a:prstGeom>
-          <a:noFill/>
-          <a:ln/>
-        </p:spPr>
-        <p:txBody>
-          <a:bodyPr wrap="square" lIns="0" tIns="0" rIns="0" bIns="0" rtlCol="0" anchor="ctr"/>
-          <a:lstStyle/>
-          <a:p>
-            <a:pPr marL="0" indent="0" algn="ctr">
-              <a:buNone/>
-            </a:pPr>
-            <a:r>
-              <a:rPr lang="en-US" sz="750" dirty="0">
-                <a:solidFill>
-                  <a:srgbClr val="FFFFFF"/>
-                </a:solidFill>
-                <a:latin typeface="Calibri" pitchFamily="34" charset="0"/>
-                <a:ea typeface="Calibri" pitchFamily="34" charset="-122"/>
-                <a:cs typeface="Calibri" pitchFamily="34" charset="-120"/>
-              </a:rPr>
-              <a:t>Em análise</a:t>
-            </a:r>
-            <a:endParaRPr lang="en-US" sz="750" dirty="0"/>
-          </a:p>
-        </p:txBody>
-      </p:sp>
-      <p:sp>
-        <p:nvSpPr>
-          <p:cNvPr id="11" name="Shape 9"/>
-          <p:cNvSpPr/>
-          <p:nvPr/>
-        </p:nvSpPr>
-        <p:spPr>
-          <a:xfrm>
-            <a:off x="3255264" y="1152144"/>
-            <a:ext cx="1353312" cy="457200"/>
-          </a:xfrm>
-          <a:prstGeom prst="rect">
-            <a:avLst/>
-          </a:prstGeom>
-          <a:solidFill>
-            <a:srgbClr val="20C997"/>
-          </a:solidFill>
-          <a:ln w="12700">
-            <a:solidFill>
-              <a:srgbClr val="20C997"/>
-            </a:solidFill>
-            <a:prstDash val="solid"/>
-          </a:ln>
-        </p:spPr>
-      </p:sp>
-      <p:sp>
-        <p:nvSpPr>
-          <p:cNvPr id="12" name="Text 10"/>
-          <p:cNvSpPr/>
-          <p:nvPr/>
-        </p:nvSpPr>
-        <p:spPr>
-          <a:xfrm>
-            <a:off x="3255264" y="1152144"/>
-            <a:ext cx="1353312" cy="274320"/>
-          </a:xfrm>
-          <a:prstGeom prst="rect">
-            <a:avLst/>
-          </a:prstGeom>
-          <a:noFill/>
-          <a:ln/>
-        </p:spPr>
-        <p:txBody>
-          <a:bodyPr wrap="square" lIns="0" tIns="0" rIns="0" bIns="0" rtlCol="0" anchor="ctr"/>
-          <a:lstStyle/>
-          <a:p>
-            <a:pPr marL="0" indent="0" algn="ctr">
-              <a:buNone/>
-            </a:pPr>
-            <a:r>
-              <a:rPr lang="en-US" sz="850" b="1" dirty="0">
-                <a:solidFill>
-                  <a:srgbClr val="FFFFFF"/>
-                </a:solidFill>
-                <a:latin typeface="Consolas" pitchFamily="34" charset="0"/>
-                <a:ea typeface="Consolas" pitchFamily="34" charset="-122"/>
-                <a:cs typeface="Consolas" pitchFamily="34" charset="-120"/>
-              </a:rPr>
-              <a:t>#20C997</a:t>
-            </a:r>
-            <a:endParaRPr lang="en-US" sz="850" dirty="0"/>
-          </a:p>
-        </p:txBody>
-      </p:sp>
-      <p:sp>
-        <p:nvSpPr>
-          <p:cNvPr id="13" name="Text 11"/>
-          <p:cNvSpPr/>
-          <p:nvPr/>
-        </p:nvSpPr>
-        <p:spPr>
-          <a:xfrm>
-            <a:off x="3255264" y="1426464"/>
-            <a:ext cx="1353312" cy="182880"/>
-          </a:xfrm>
-          <a:prstGeom prst="rect">
-            <a:avLst/>
-          </a:prstGeom>
-          <a:noFill/>
-          <a:ln/>
-        </p:spPr>
-        <p:txBody>
-          <a:bodyPr wrap="square" lIns="0" tIns="0" rIns="0" bIns="0" rtlCol="0" anchor="ctr"/>
-          <a:lstStyle/>
-          <a:p>
-            <a:pPr marL="0" indent="0" algn="ctr">
-              <a:buNone/>
-            </a:pPr>
-            <a:r>
-              <a:rPr lang="en-US" sz="750" dirty="0">
-                <a:solidFill>
-                  <a:srgbClr val="FFFFFF"/>
-                </a:solidFill>
-                <a:latin typeface="Calibri" pitchFamily="34" charset="0"/>
-                <a:ea typeface="Calibri" pitchFamily="34" charset="-122"/>
-                <a:cs typeface="Calibri" pitchFamily="34" charset="-120"/>
-              </a:rPr>
-              <a:t>Em atendimento</a:t>
-            </a:r>
-            <a:endParaRPr lang="en-US" sz="750" dirty="0"/>
-          </a:p>
-        </p:txBody>
-      </p:sp>
-      <p:sp>
-        <p:nvSpPr>
-          <p:cNvPr id="14" name="Shape 12"/>
-          <p:cNvSpPr/>
-          <p:nvPr/>
-        </p:nvSpPr>
-        <p:spPr>
-          <a:xfrm>
-            <a:off x="4700016" y="1152144"/>
-            <a:ext cx="1353312" cy="457200"/>
-          </a:xfrm>
-          <a:prstGeom prst="rect">
-            <a:avLst/>
-          </a:prstGeom>
-          <a:solidFill>
-            <a:srgbClr val="FD7E14"/>
-          </a:solidFill>
-          <a:ln w="12700">
-            <a:solidFill>
-              <a:srgbClr val="FD7E14"/>
-            </a:solidFill>
-            <a:prstDash val="solid"/>
-          </a:ln>
-        </p:spPr>
-      </p:sp>
-      <p:sp>
-        <p:nvSpPr>
-          <p:cNvPr id="15" name="Text 13"/>
-          <p:cNvSpPr/>
-          <p:nvPr/>
-        </p:nvSpPr>
-        <p:spPr>
-          <a:xfrm>
-            <a:off x="4700016" y="1152144"/>
-            <a:ext cx="1353312" cy="274320"/>
-          </a:xfrm>
-          <a:prstGeom prst="rect">
-            <a:avLst/>
-          </a:prstGeom>
-          <a:noFill/>
-          <a:ln/>
-        </p:spPr>
-        <p:txBody>
-          <a:bodyPr wrap="square" lIns="0" tIns="0" rIns="0" bIns="0" rtlCol="0" anchor="ctr"/>
-          <a:lstStyle/>
-          <a:p>
-            <a:pPr marL="0" indent="0" algn="ctr">
-              <a:buNone/>
-            </a:pPr>
-            <a:r>
-              <a:rPr lang="en-US" sz="850" b="1" dirty="0">
-                <a:solidFill>
-                  <a:srgbClr val="FFFFFF"/>
-                </a:solidFill>
-                <a:latin typeface="Consolas" pitchFamily="34" charset="0"/>
-                <a:ea typeface="Consolas" pitchFamily="34" charset="-122"/>
-                <a:cs typeface="Consolas" pitchFamily="34" charset="-120"/>
-              </a:rPr>
-              <a:t>#FD7E14</a:t>
-            </a:r>
-            <a:endParaRPr lang="en-US" sz="850" dirty="0"/>
-          </a:p>
-        </p:txBody>
-      </p:sp>
-      <p:sp>
-        <p:nvSpPr>
-          <p:cNvPr id="16" name="Text 14"/>
-          <p:cNvSpPr/>
-          <p:nvPr/>
-        </p:nvSpPr>
-        <p:spPr>
-          <a:xfrm>
-            <a:off x="4700016" y="1426464"/>
-            <a:ext cx="1353312" cy="182880"/>
-          </a:xfrm>
-          <a:prstGeom prst="rect">
-            <a:avLst/>
-          </a:prstGeom>
-          <a:noFill/>
-          <a:ln/>
-        </p:spPr>
-        <p:txBody>
-          <a:bodyPr wrap="square" lIns="0" tIns="0" rIns="0" bIns="0" rtlCol="0" anchor="ctr"/>
-          <a:lstStyle/>
-          <a:p>
-            <a:pPr marL="0" indent="0" algn="ctr">
-              <a:buNone/>
-            </a:pPr>
-            <a:r>
-              <a:rPr lang="en-US" sz="750" dirty="0">
-                <a:solidFill>
-                  <a:srgbClr val="FFFFFF"/>
-                </a:solidFill>
-                <a:latin typeface="Calibri" pitchFamily="34" charset="0"/>
-                <a:ea typeface="Calibri" pitchFamily="34" charset="-122"/>
-                <a:cs typeface="Calibri" pitchFamily="34" charset="-120"/>
-              </a:rPr>
-              <a:t>Aguardando cliente</a:t>
-            </a:r>
-            <a:endParaRPr lang="en-US" sz="750" dirty="0"/>
-          </a:p>
-        </p:txBody>
-      </p:sp>
-      <p:sp>
-        <p:nvSpPr>
-          <p:cNvPr id="17" name="Shape 15"/>
-          <p:cNvSpPr/>
-          <p:nvPr/>
-        </p:nvSpPr>
-        <p:spPr>
-          <a:xfrm>
-            <a:off x="6144768" y="1152144"/>
-            <a:ext cx="1353312" cy="457200"/>
-          </a:xfrm>
-          <a:prstGeom prst="rect">
-            <a:avLst/>
-          </a:prstGeom>
-          <a:solidFill>
-            <a:srgbClr val="198754"/>
-          </a:solidFill>
-          <a:ln w="12700">
-            <a:solidFill>
-              <a:srgbClr val="198754"/>
-            </a:solidFill>
-            <a:prstDash val="solid"/>
-          </a:ln>
-        </p:spPr>
-      </p:sp>
-      <p:sp>
-        <p:nvSpPr>
-          <p:cNvPr id="18" name="Text 16"/>
-          <p:cNvSpPr/>
-          <p:nvPr/>
-        </p:nvSpPr>
-        <p:spPr>
-          <a:xfrm>
-            <a:off x="6144768" y="1152144"/>
-            <a:ext cx="1353312" cy="274320"/>
-          </a:xfrm>
-          <a:prstGeom prst="rect">
-            <a:avLst/>
-          </a:prstGeom>
-          <a:noFill/>
-          <a:ln/>
-        </p:spPr>
-        <p:txBody>
-          <a:bodyPr wrap="square" lIns="0" tIns="0" rIns="0" bIns="0" rtlCol="0" anchor="ctr"/>
-          <a:lstStyle/>
-          <a:p>
-            <a:pPr marL="0" indent="0" algn="ctr">
-              <a:buNone/>
-            </a:pPr>
-            <a:r>
-              <a:rPr lang="en-US" sz="850" b="1" dirty="0">
-                <a:solidFill>
-                  <a:srgbClr val="FFFFFF"/>
-                </a:solidFill>
-                <a:latin typeface="Consolas" pitchFamily="34" charset="0"/>
-                <a:ea typeface="Consolas" pitchFamily="34" charset="-122"/>
-                <a:cs typeface="Consolas" pitchFamily="34" charset="-120"/>
-              </a:rPr>
-              <a:t>#198754</a:t>
-            </a:r>
-            <a:endParaRPr lang="en-US" sz="850" dirty="0"/>
-          </a:p>
-        </p:txBody>
-      </p:sp>
-      <p:sp>
-        <p:nvSpPr>
-          <p:cNvPr id="19" name="Text 17"/>
-          <p:cNvSpPr/>
-          <p:nvPr/>
-        </p:nvSpPr>
-        <p:spPr>
-          <a:xfrm>
-            <a:off x="6144768" y="1426464"/>
-            <a:ext cx="1353312" cy="182880"/>
-          </a:xfrm>
-          <a:prstGeom prst="rect">
-            <a:avLst/>
-          </a:prstGeom>
-          <a:noFill/>
-          <a:ln/>
-        </p:spPr>
-        <p:txBody>
-          <a:bodyPr wrap="square" lIns="0" tIns="0" rIns="0" bIns="0" rtlCol="0" anchor="ctr"/>
-          <a:lstStyle/>
-          <a:p>
-            <a:pPr marL="0" indent="0" algn="ctr">
-              <a:buNone/>
-            </a:pPr>
-            <a:r>
-              <a:rPr lang="en-US" sz="750" dirty="0">
-                <a:solidFill>
-                  <a:srgbClr val="FFFFFF"/>
-                </a:solidFill>
-                <a:latin typeface="Calibri" pitchFamily="34" charset="0"/>
-                <a:ea typeface="Calibri" pitchFamily="34" charset="-122"/>
-                <a:cs typeface="Calibri" pitchFamily="34" charset="-120"/>
-              </a:rPr>
-              <a:t>Resolvido</a:t>
-            </a:r>
-            <a:endParaRPr lang="en-US" sz="750" dirty="0"/>
-          </a:p>
-        </p:txBody>
-      </p:sp>
-      <p:sp>
-        <p:nvSpPr>
-          <p:cNvPr id="20" name="Shape 18"/>
-          <p:cNvSpPr/>
-          <p:nvPr/>
-        </p:nvSpPr>
-        <p:spPr>
-          <a:xfrm>
-            <a:off x="7589520" y="1152144"/>
-            <a:ext cx="1353312" cy="457200"/>
-          </a:xfrm>
-          <a:prstGeom prst="rect">
-            <a:avLst/>
-          </a:prstGeom>
-          <a:solidFill>
-            <a:srgbClr val="6C757D"/>
-          </a:solidFill>
-          <a:ln w="12700">
-            <a:solidFill>
-              <a:srgbClr val="6C757D"/>
-            </a:solidFill>
-            <a:prstDash val="solid"/>
-          </a:ln>
-        </p:spPr>
-      </p:sp>
-      <p:sp>
-        <p:nvSpPr>
-          <p:cNvPr id="21" name="Text 19"/>
-          <p:cNvSpPr/>
-          <p:nvPr/>
-        </p:nvSpPr>
-        <p:spPr>
-          <a:xfrm>
-            <a:off x="7589520" y="1152144"/>
-            <a:ext cx="1353312" cy="274320"/>
-          </a:xfrm>
-          <a:prstGeom prst="rect">
-            <a:avLst/>
-          </a:prstGeom>
-          <a:noFill/>
-          <a:ln/>
-        </p:spPr>
-        <p:txBody>
-          <a:bodyPr wrap="square" lIns="0" tIns="0" rIns="0" bIns="0" rtlCol="0" anchor="ctr"/>
-          <a:lstStyle/>
-          <a:p>
-            <a:pPr marL="0" indent="0" algn="ctr">
-              <a:buNone/>
-            </a:pPr>
-            <a:r>
-              <a:rPr lang="en-US" sz="850" b="1" dirty="0">
-                <a:solidFill>
-                  <a:srgbClr val="FFFFFF"/>
-                </a:solidFill>
-                <a:latin typeface="Consolas" pitchFamily="34" charset="0"/>
-                <a:ea typeface="Consolas" pitchFamily="34" charset="-122"/>
-                <a:cs typeface="Consolas" pitchFamily="34" charset="-120"/>
-              </a:rPr>
-              <a:t>#6C757D</a:t>
-            </a:r>
-            <a:endParaRPr lang="en-US" sz="850" dirty="0"/>
-          </a:p>
-        </p:txBody>
-      </p:sp>
-      <p:sp>
-        <p:nvSpPr>
-          <p:cNvPr id="22" name="Text 20"/>
-          <p:cNvSpPr/>
-          <p:nvPr/>
-        </p:nvSpPr>
-        <p:spPr>
-          <a:xfrm>
-            <a:off x="7589520" y="1426464"/>
-            <a:ext cx="1353312" cy="182880"/>
-          </a:xfrm>
-          <a:prstGeom prst="rect">
-            <a:avLst/>
-          </a:prstGeom>
-          <a:noFill/>
-          <a:ln/>
-        </p:spPr>
-        <p:txBody>
-          <a:bodyPr wrap="square" lIns="0" tIns="0" rIns="0" bIns="0" rtlCol="0" anchor="ctr"/>
-          <a:lstStyle/>
-          <a:p>
-            <a:pPr marL="0" indent="0" algn="ctr">
-              <a:buNone/>
-            </a:pPr>
-            <a:r>
-              <a:rPr lang="en-US" sz="750" dirty="0">
-                <a:solidFill>
-                  <a:srgbClr val="FFFFFF"/>
-                </a:solidFill>
-                <a:latin typeface="Calibri" pitchFamily="34" charset="0"/>
-                <a:ea typeface="Calibri" pitchFamily="34" charset="-122"/>
-                <a:cs typeface="Calibri" pitchFamily="34" charset="-120"/>
-              </a:rPr>
-              <a:t>Fechado</a:t>
-            </a:r>
-            <a:endParaRPr lang="en-US" sz="750" dirty="0"/>
-          </a:p>
-        </p:txBody>
-      </p:sp>
-      <p:sp>
-        <p:nvSpPr>
-          <p:cNvPr id="23" name="Text 21"/>
-          <p:cNvSpPr/>
-          <p:nvPr/>
-        </p:nvSpPr>
-        <p:spPr>
-          <a:xfrm>
-            <a:off x="365760" y="1719072"/>
-            <a:ext cx="8412480" cy="237744"/>
-          </a:xfrm>
-          <a:prstGeom prst="rect">
-            <a:avLst/>
-          </a:prstGeom>
-          <a:noFill/>
-          <a:ln/>
-        </p:spPr>
-        <p:txBody>
-          <a:bodyPr wrap="square" lIns="0" tIns="0" rIns="0" bIns="0" rtlCol="0" anchor="ctr"/>
-          <a:lstStyle/>
-          <a:p>
-            <a:pPr marL="0" indent="0">
-              <a:buNone/>
-            </a:pPr>
-            <a:r>
-              <a:rPr lang="en-US" sz="1100" b="1" dirty="0">
-                <a:solidFill>
-                  <a:srgbClr val="2D3463"/>
-                </a:solidFill>
-                <a:latin typeface="Calibri" pitchFamily="34" charset="0"/>
-                <a:ea typeface="Calibri" pitchFamily="34" charset="-122"/>
-                <a:cs typeface="Calibri" pitchFamily="34" charset="-120"/>
-              </a:rPr>
-              <a:t>Prioridades</a:t>
-            </a:r>
-            <a:endParaRPr lang="en-US" sz="1100" dirty="0"/>
-          </a:p>
-        </p:txBody>
-      </p:sp>
-      <p:sp>
-        <p:nvSpPr>
-          <p:cNvPr id="24" name="Shape 22"/>
-          <p:cNvSpPr/>
-          <p:nvPr/>
-        </p:nvSpPr>
-        <p:spPr>
-          <a:xfrm>
-            <a:off x="365760" y="1993392"/>
-            <a:ext cx="2066544" cy="420624"/>
-          </a:xfrm>
-          <a:prstGeom prst="rect">
-            <a:avLst/>
-          </a:prstGeom>
-          <a:solidFill>
-            <a:srgbClr val="6C757D"/>
-          </a:solidFill>
-          <a:ln w="12700">
-            <a:solidFill>
-              <a:srgbClr val="6C757D"/>
-            </a:solidFill>
-            <a:prstDash val="solid"/>
-          </a:ln>
-        </p:spPr>
-      </p:sp>
-      <p:sp>
-        <p:nvSpPr>
-          <p:cNvPr id="25" name="Text 23"/>
-          <p:cNvSpPr/>
-          <p:nvPr/>
-        </p:nvSpPr>
-        <p:spPr>
-          <a:xfrm>
-            <a:off x="365760" y="1993392"/>
-            <a:ext cx="2066544" cy="420624"/>
-          </a:xfrm>
-          <a:prstGeom prst="rect">
-            <a:avLst/>
-          </a:prstGeom>
-          <a:noFill/>
-          <a:ln/>
-        </p:spPr>
-        <p:txBody>
-          <a:bodyPr wrap="square" lIns="0" tIns="0" rIns="0" bIns="0" rtlCol="0" anchor="ctr"/>
-          <a:lstStyle/>
-          <a:p>
-            <a:pPr marL="0" indent="0" algn="ctr">
-              <a:buNone/>
-            </a:pPr>
-            <a:r>
-              <a:rPr lang="en-US" sz="1000" b="1" dirty="0">
-                <a:solidFill>
-                  <a:srgbClr val="FFFFFF"/>
-                </a:solidFill>
-                <a:latin typeface="Calibri" pitchFamily="34" charset="0"/>
-                <a:ea typeface="Calibri" pitchFamily="34" charset="-122"/>
-                <a:cs typeface="Calibri" pitchFamily="34" charset="-120"/>
-              </a:rPr>
-              <a:t>#6C757D  ·  Baixa</a:t>
-            </a:r>
-            <a:endParaRPr lang="en-US" sz="1000" dirty="0"/>
-          </a:p>
-        </p:txBody>
-      </p:sp>
-      <p:sp>
-        <p:nvSpPr>
-          <p:cNvPr id="26" name="Shape 24"/>
-          <p:cNvSpPr/>
-          <p:nvPr/>
-        </p:nvSpPr>
-        <p:spPr>
-          <a:xfrm>
-            <a:off x="2523744" y="1993392"/>
-            <a:ext cx="2066544" cy="420624"/>
-          </a:xfrm>
-          <a:prstGeom prst="rect">
-            <a:avLst/>
-          </a:prstGeom>
-          <a:solidFill>
-            <a:srgbClr val="0D6EFD"/>
-          </a:solidFill>
-          <a:ln w="12700">
-            <a:solidFill>
-              <a:srgbClr val="0D6EFD"/>
-            </a:solidFill>
-            <a:prstDash val="solid"/>
-          </a:ln>
-        </p:spPr>
-      </p:sp>
-      <p:sp>
-        <p:nvSpPr>
-          <p:cNvPr id="27" name="Text 25"/>
-          <p:cNvSpPr/>
-          <p:nvPr/>
-        </p:nvSpPr>
-        <p:spPr>
-          <a:xfrm>
-            <a:off x="2523744" y="1993392"/>
-            <a:ext cx="2066544" cy="420624"/>
-          </a:xfrm>
-          <a:prstGeom prst="rect">
-            <a:avLst/>
-          </a:prstGeom>
-          <a:noFill/>
-          <a:ln/>
-        </p:spPr>
-        <p:txBody>
-          <a:bodyPr wrap="square" lIns="0" tIns="0" rIns="0" bIns="0" rtlCol="0" anchor="ctr"/>
-          <a:lstStyle/>
-          <a:p>
-            <a:pPr marL="0" indent="0" algn="ctr">
-              <a:buNone/>
-            </a:pPr>
-            <a:r>
-              <a:rPr lang="en-US" sz="1000" b="1" dirty="0">
-                <a:solidFill>
-                  <a:srgbClr val="FFFFFF"/>
-                </a:solidFill>
-                <a:latin typeface="Calibri" pitchFamily="34" charset="0"/>
-                <a:ea typeface="Calibri" pitchFamily="34" charset="-122"/>
-                <a:cs typeface="Calibri" pitchFamily="34" charset="-120"/>
-              </a:rPr>
-              <a:t>#0D6EFD  ·  Média</a:t>
-            </a:r>
-            <a:endParaRPr lang="en-US" sz="1000" dirty="0"/>
-          </a:p>
-        </p:txBody>
-      </p:sp>
-      <p:sp>
-        <p:nvSpPr>
-          <p:cNvPr id="28" name="Shape 26"/>
-          <p:cNvSpPr/>
-          <p:nvPr/>
-        </p:nvSpPr>
-        <p:spPr>
-          <a:xfrm>
-            <a:off x="4681728" y="1993392"/>
-            <a:ext cx="2066544" cy="420624"/>
-          </a:xfrm>
-          <a:prstGeom prst="rect">
-            <a:avLst/>
-          </a:prstGeom>
-          <a:solidFill>
-            <a:srgbClr val="FD7E14"/>
-          </a:solidFill>
-          <a:ln w="12700">
-            <a:solidFill>
-              <a:srgbClr val="FD7E14"/>
-            </a:solidFill>
-            <a:prstDash val="solid"/>
-          </a:ln>
-        </p:spPr>
-      </p:sp>
-      <p:sp>
-        <p:nvSpPr>
-          <p:cNvPr id="29" name="Text 27"/>
-          <p:cNvSpPr/>
-          <p:nvPr/>
-        </p:nvSpPr>
-        <p:spPr>
-          <a:xfrm>
-            <a:off x="4681728" y="1993392"/>
-            <a:ext cx="2066544" cy="420624"/>
-          </a:xfrm>
-          <a:prstGeom prst="rect">
-            <a:avLst/>
-          </a:prstGeom>
-          <a:noFill/>
-          <a:ln/>
-        </p:spPr>
-        <p:txBody>
-          <a:bodyPr wrap="square" lIns="0" tIns="0" rIns="0" bIns="0" rtlCol="0" anchor="ctr"/>
-          <a:lstStyle/>
-          <a:p>
-            <a:pPr marL="0" indent="0" algn="ctr">
-              <a:buNone/>
-            </a:pPr>
-            <a:r>
-              <a:rPr lang="en-US" sz="1000" b="1" dirty="0">
-                <a:solidFill>
-                  <a:srgbClr val="FFFFFF"/>
-                </a:solidFill>
-                <a:latin typeface="Calibri" pitchFamily="34" charset="0"/>
-                <a:ea typeface="Calibri" pitchFamily="34" charset="-122"/>
-                <a:cs typeface="Calibri" pitchFamily="34" charset="-120"/>
-              </a:rPr>
-              <a:t>#FD7E14  ·  Alta</a:t>
-            </a:r>
-            <a:endParaRPr lang="en-US" sz="1000" dirty="0"/>
-          </a:p>
-        </p:txBody>
-      </p:sp>
-      <p:sp>
-        <p:nvSpPr>
-          <p:cNvPr id="30" name="Shape 28"/>
-          <p:cNvSpPr/>
-          <p:nvPr/>
-        </p:nvSpPr>
-        <p:spPr>
-          <a:xfrm>
-            <a:off x="6839712" y="1993392"/>
-            <a:ext cx="2066544" cy="420624"/>
-          </a:xfrm>
-          <a:prstGeom prst="rect">
-            <a:avLst/>
-          </a:prstGeom>
-          <a:solidFill>
-            <a:srgbClr val="DC3545"/>
-          </a:solidFill>
-          <a:ln w="12700">
-            <a:solidFill>
-              <a:srgbClr val="DC3545"/>
-            </a:solidFill>
-            <a:prstDash val="solid"/>
-          </a:ln>
-        </p:spPr>
-      </p:sp>
-      <p:sp>
-        <p:nvSpPr>
-          <p:cNvPr id="31" name="Text 29"/>
-          <p:cNvSpPr/>
-          <p:nvPr/>
-        </p:nvSpPr>
-        <p:spPr>
-          <a:xfrm>
-            <a:off x="6839712" y="1993392"/>
-            <a:ext cx="2066544" cy="420624"/>
-          </a:xfrm>
-          <a:prstGeom prst="rect">
-            <a:avLst/>
-          </a:prstGeom>
-          <a:noFill/>
-          <a:ln/>
-        </p:spPr>
-        <p:txBody>
-          <a:bodyPr wrap="square" lIns="0" tIns="0" rIns="0" bIns="0" rtlCol="0" anchor="ctr"/>
-          <a:lstStyle/>
-          <a:p>
-            <a:pPr marL="0" indent="0" algn="ctr">
-              <a:buNone/>
-            </a:pPr>
-            <a:r>
-              <a:rPr lang="en-US" sz="1000" b="1" dirty="0">
-                <a:solidFill>
-                  <a:srgbClr val="FFFFFF"/>
-                </a:solidFill>
-                <a:latin typeface="Calibri" pitchFamily="34" charset="0"/>
-                <a:ea typeface="Calibri" pitchFamily="34" charset="-122"/>
-                <a:cs typeface="Calibri" pitchFamily="34" charset="-120"/>
-              </a:rPr>
-              <a:t>#DC3545  ·  Urgente</a:t>
-            </a:r>
-            <a:endParaRPr lang="en-US" sz="1000" dirty="0"/>
-          </a:p>
-        </p:txBody>
-      </p:sp>
-      <p:sp>
-        <p:nvSpPr>
-          <p:cNvPr id="50" name="Text 48"/>
-          <p:cNvSpPr/>
-          <p:nvPr/>
-        </p:nvSpPr>
-        <p:spPr>
-          <a:xfrm>
-            <a:off x="365760" y="4041648"/>
-            <a:ext cx="8412480" cy="256032"/>
-          </a:xfrm>
-          <a:prstGeom prst="rect">
-            <a:avLst/>
-          </a:prstGeom>
-          <a:noFill/>
-          <a:ln/>
-        </p:spPr>
-        <p:txBody>
-          <a:bodyPr wrap="square" lIns="0" tIns="0" rIns="0" bIns="0" rtlCol="0" anchor="ctr"/>
-          <a:lstStyle/>
-          <a:p>
-            <a:pPr marL="0" indent="0">
-              <a:buNone/>
-            </a:pPr>
-            <a:r>
-              <a:rPr lang="en-US" sz="1100" b="1" dirty="0">
-                <a:solidFill>
-                  <a:srgbClr val="2D3463"/>
-                </a:solidFill>
-                <a:latin typeface="Calibri" pitchFamily="34" charset="0"/>
-                <a:ea typeface="Calibri" pitchFamily="34" charset="-122"/>
-                <a:cs typeface="Calibri" pitchFamily="34" charset="-120"/>
-              </a:rPr>
-              <a:t>Formato do Protocolo Único</a:t>
-            </a:r>
-            <a:endParaRPr lang="en-US" sz="1100" dirty="0"/>
-          </a:p>
-        </p:txBody>
-      </p:sp>
-      <p:sp>
-        <p:nvSpPr>
-          <p:cNvPr id="51" name="Shape 49"/>
-          <p:cNvSpPr/>
-          <p:nvPr/>
-        </p:nvSpPr>
-        <p:spPr>
-          <a:xfrm>
-            <a:off x="731520" y="4343400"/>
-            <a:ext cx="512064" cy="420624"/>
-          </a:xfrm>
-          <a:prstGeom prst="rect">
-            <a:avLst/>
-          </a:prstGeom>
-          <a:solidFill>
-            <a:srgbClr val="EEF0FB"/>
-          </a:solidFill>
-          <a:ln w="12700">
-            <a:solidFill>
-              <a:srgbClr val="C5CCE8"/>
-            </a:solidFill>
-            <a:prstDash val="solid"/>
-          </a:ln>
-        </p:spPr>
-      </p:sp>
-      <p:sp>
-        <p:nvSpPr>
-          <p:cNvPr id="52" name="Text 50"/>
-          <p:cNvSpPr/>
-          <p:nvPr/>
-        </p:nvSpPr>
-        <p:spPr>
-          <a:xfrm>
-            <a:off x="731520" y="4343400"/>
-            <a:ext cx="512064" cy="237744"/>
-          </a:xfrm>
-          <a:prstGeom prst="rect">
-            <a:avLst/>
-          </a:prstGeom>
-          <a:noFill/>
-          <a:ln/>
-        </p:spPr>
-        <p:txBody>
-          <a:bodyPr wrap="square" lIns="0" tIns="0" rIns="0" bIns="0" rtlCol="0" anchor="ctr"/>
-          <a:lstStyle/>
-          <a:p>
-            <a:pPr marL="0" indent="0" algn="ctr">
-              <a:buNone/>
-            </a:pPr>
-            <a:r>
-              <a:rPr lang="en-US" sz="1100" b="1" dirty="0">
-                <a:solidFill>
-                  <a:srgbClr val="4F5DA3"/>
-                </a:solidFill>
-                <a:latin typeface="Consolas" pitchFamily="34" charset="0"/>
-                <a:ea typeface="Consolas" pitchFamily="34" charset="-122"/>
-                <a:cs typeface="Consolas" pitchFamily="34" charset="-120"/>
-              </a:rPr>
-              <a:t>CH</a:t>
-            </a:r>
-            <a:endParaRPr lang="en-US" sz="1100" dirty="0"/>
-          </a:p>
-        </p:txBody>
-      </p:sp>
-      <p:sp>
-        <p:nvSpPr>
-          <p:cNvPr id="53" name="Text 51"/>
-          <p:cNvSpPr/>
-          <p:nvPr/>
-        </p:nvSpPr>
-        <p:spPr>
-          <a:xfrm>
-            <a:off x="731520" y="4581144"/>
-            <a:ext cx="512064" cy="182880"/>
-          </a:xfrm>
-          <a:prstGeom prst="rect">
-            <a:avLst/>
-          </a:prstGeom>
-          <a:noFill/>
-          <a:ln/>
-        </p:spPr>
-        <p:txBody>
-          <a:bodyPr wrap="square" lIns="0" tIns="0" rIns="0" bIns="0" rtlCol="0" anchor="ctr"/>
-          <a:lstStyle/>
-          <a:p>
-            <a:pPr marL="0" indent="0" algn="ctr">
-              <a:buNone/>
-            </a:pPr>
-            <a:r>
-              <a:rPr lang="en-US" sz="750" dirty="0">
-                <a:solidFill>
-                  <a:srgbClr val="6B7280"/>
-                </a:solidFill>
-                <a:latin typeface="Calibri" pitchFamily="34" charset="0"/>
-                <a:ea typeface="Calibri" pitchFamily="34" charset="-122"/>
-                <a:cs typeface="Calibri" pitchFamily="34" charset="-120"/>
-              </a:rPr>
-              <a:t>Prefixo fixo</a:t>
-            </a:r>
-            <a:endParaRPr lang="en-US" sz="750" dirty="0"/>
-          </a:p>
-        </p:txBody>
-      </p:sp>
-      <p:sp>
-        <p:nvSpPr>
-          <p:cNvPr id="54" name="Shape 52"/>
-          <p:cNvSpPr/>
-          <p:nvPr/>
-        </p:nvSpPr>
-        <p:spPr>
-          <a:xfrm>
-            <a:off x="1335024" y="4343400"/>
-            <a:ext cx="585216" cy="420624"/>
-          </a:xfrm>
-          <a:prstGeom prst="rect">
-            <a:avLst/>
-          </a:prstGeom>
-          <a:solidFill>
-            <a:srgbClr val="EEF0FB"/>
-          </a:solidFill>
-          <a:ln w="12700">
-            <a:solidFill>
-              <a:srgbClr val="C5CCE8"/>
-            </a:solidFill>
-            <a:prstDash val="solid"/>
-          </a:ln>
-        </p:spPr>
-      </p:sp>
-      <p:sp>
-        <p:nvSpPr>
-          <p:cNvPr id="55" name="Text 53"/>
-          <p:cNvSpPr/>
-          <p:nvPr/>
-        </p:nvSpPr>
-        <p:spPr>
-          <a:xfrm>
-            <a:off x="1335024" y="4343400"/>
-            <a:ext cx="585216" cy="237744"/>
-          </a:xfrm>
-          <a:prstGeom prst="rect">
-            <a:avLst/>
-          </a:prstGeom>
-          <a:noFill/>
-          <a:ln/>
-        </p:spPr>
-        <p:txBody>
-          <a:bodyPr wrap="square" lIns="0" tIns="0" rIns="0" bIns="0" rtlCol="0" anchor="ctr"/>
-          <a:lstStyle/>
-          <a:p>
-            <a:pPr marL="0" indent="0" algn="ctr">
-              <a:buNone/>
-            </a:pPr>
-            <a:r>
-              <a:rPr lang="en-US" sz="1100" b="1" dirty="0">
-                <a:solidFill>
-                  <a:srgbClr val="4F5DA3"/>
-                </a:solidFill>
-                <a:latin typeface="Consolas" pitchFamily="34" charset="0"/>
-                <a:ea typeface="Consolas" pitchFamily="34" charset="-122"/>
-                <a:cs typeface="Consolas" pitchFamily="34" charset="-120"/>
-              </a:rPr>
-              <a:t>2026</a:t>
-            </a:r>
-            <a:endParaRPr lang="en-US" sz="1100" dirty="0"/>
-          </a:p>
-        </p:txBody>
-      </p:sp>
-      <p:sp>
-        <p:nvSpPr>
-          <p:cNvPr id="56" name="Text 54"/>
-          <p:cNvSpPr/>
-          <p:nvPr/>
-        </p:nvSpPr>
-        <p:spPr>
-          <a:xfrm>
-            <a:off x="1335024" y="4581144"/>
-            <a:ext cx="585216" cy="182880"/>
-          </a:xfrm>
-          <a:prstGeom prst="rect">
-            <a:avLst/>
-          </a:prstGeom>
-          <a:noFill/>
-          <a:ln/>
-        </p:spPr>
-        <p:txBody>
-          <a:bodyPr wrap="square" lIns="0" tIns="0" rIns="0" bIns="0" rtlCol="0" anchor="ctr"/>
-          <a:lstStyle/>
-          <a:p>
-            <a:pPr marL="0" indent="0" algn="ctr">
-              <a:buNone/>
-            </a:pPr>
-            <a:r>
-              <a:rPr lang="en-US" sz="750" dirty="0">
-                <a:solidFill>
-                  <a:srgbClr val="6B7280"/>
-                </a:solidFill>
-                <a:latin typeface="Calibri" pitchFamily="34" charset="0"/>
-                <a:ea typeface="Calibri" pitchFamily="34" charset="-122"/>
-                <a:cs typeface="Calibri" pitchFamily="34" charset="-120"/>
-              </a:rPr>
-              <a:t>Ano</a:t>
-            </a:r>
-            <a:endParaRPr lang="en-US" sz="750" dirty="0"/>
-          </a:p>
-        </p:txBody>
-      </p:sp>
-      <p:sp>
-        <p:nvSpPr>
-          <p:cNvPr id="57" name="Shape 55"/>
-          <p:cNvSpPr/>
-          <p:nvPr/>
-        </p:nvSpPr>
-        <p:spPr>
-          <a:xfrm>
-            <a:off x="2011680" y="4343400"/>
-            <a:ext cx="438912" cy="420624"/>
-          </a:xfrm>
-          <a:prstGeom prst="rect">
-            <a:avLst/>
-          </a:prstGeom>
-          <a:solidFill>
-            <a:srgbClr val="EEF0FB"/>
-          </a:solidFill>
-          <a:ln w="12700">
-            <a:solidFill>
-              <a:srgbClr val="C5CCE8"/>
-            </a:solidFill>
-            <a:prstDash val="solid"/>
-          </a:ln>
-        </p:spPr>
-      </p:sp>
-      <p:sp>
-        <p:nvSpPr>
-          <p:cNvPr id="58" name="Text 56"/>
-          <p:cNvSpPr/>
-          <p:nvPr/>
-        </p:nvSpPr>
-        <p:spPr>
-          <a:xfrm>
-            <a:off x="2011680" y="4343400"/>
-            <a:ext cx="438912" cy="237744"/>
-          </a:xfrm>
-          <a:prstGeom prst="rect">
-            <a:avLst/>
-          </a:prstGeom>
-          <a:noFill/>
-          <a:ln/>
-        </p:spPr>
-        <p:txBody>
-          <a:bodyPr wrap="square" lIns="0" tIns="0" rIns="0" bIns="0" rtlCol="0" anchor="ctr"/>
-          <a:lstStyle/>
-          <a:p>
-            <a:pPr marL="0" indent="0" algn="ctr">
-              <a:buNone/>
-            </a:pPr>
-            <a:r>
-              <a:rPr lang="en-US" sz="1100" b="1" dirty="0">
-                <a:solidFill>
-                  <a:srgbClr val="4F5DA3"/>
-                </a:solidFill>
-                <a:latin typeface="Consolas" pitchFamily="34" charset="0"/>
-                <a:ea typeface="Consolas" pitchFamily="34" charset="-122"/>
-                <a:cs typeface="Consolas" pitchFamily="34" charset="-120"/>
-              </a:rPr>
-              <a:t>02</a:t>
-            </a:r>
-            <a:endParaRPr lang="en-US" sz="1100" dirty="0"/>
-          </a:p>
-        </p:txBody>
-      </p:sp>
-      <p:sp>
-        <p:nvSpPr>
-          <p:cNvPr id="59" name="Text 57"/>
-          <p:cNvSpPr/>
-          <p:nvPr/>
-        </p:nvSpPr>
-        <p:spPr>
-          <a:xfrm>
-            <a:off x="2011680" y="4581144"/>
-            <a:ext cx="438912" cy="182880"/>
-          </a:xfrm>
-          <a:prstGeom prst="rect">
-            <a:avLst/>
-          </a:prstGeom>
-          <a:noFill/>
-          <a:ln/>
-        </p:spPr>
-        <p:txBody>
-          <a:bodyPr wrap="square" lIns="0" tIns="0" rIns="0" bIns="0" rtlCol="0" anchor="ctr"/>
-          <a:lstStyle/>
-          <a:p>
-            <a:pPr marL="0" indent="0" algn="ctr">
-              <a:buNone/>
-            </a:pPr>
-            <a:r>
-              <a:rPr lang="en-US" sz="750" dirty="0">
-                <a:solidFill>
-                  <a:srgbClr val="6B7280"/>
-                </a:solidFill>
-                <a:latin typeface="Calibri" pitchFamily="34" charset="0"/>
-                <a:ea typeface="Calibri" pitchFamily="34" charset="-122"/>
-                <a:cs typeface="Calibri" pitchFamily="34" charset="-120"/>
-              </a:rPr>
-              <a:t>Mês</a:t>
-            </a:r>
-            <a:endParaRPr lang="en-US" sz="750" dirty="0"/>
-          </a:p>
-        </p:txBody>
-      </p:sp>
-      <p:sp>
-        <p:nvSpPr>
-          <p:cNvPr id="60" name="Shape 58"/>
-          <p:cNvSpPr/>
-          <p:nvPr/>
-        </p:nvSpPr>
-        <p:spPr>
-          <a:xfrm>
-            <a:off x="2542032" y="4343400"/>
-            <a:ext cx="438912" cy="420624"/>
-          </a:xfrm>
-          <a:prstGeom prst="rect">
-            <a:avLst/>
-          </a:prstGeom>
-          <a:solidFill>
-            <a:srgbClr val="EEF0FB"/>
-          </a:solidFill>
-          <a:ln w="12700">
-            <a:solidFill>
-              <a:srgbClr val="C5CCE8"/>
-            </a:solidFill>
-            <a:prstDash val="solid"/>
-          </a:ln>
-        </p:spPr>
-      </p:sp>
-      <p:sp>
-        <p:nvSpPr>
-          <p:cNvPr id="61" name="Text 59"/>
-          <p:cNvSpPr/>
-          <p:nvPr/>
-        </p:nvSpPr>
-        <p:spPr>
-          <a:xfrm>
-            <a:off x="2542032" y="4343400"/>
-            <a:ext cx="438912" cy="237744"/>
-          </a:xfrm>
-          <a:prstGeom prst="rect">
-            <a:avLst/>
-          </a:prstGeom>
-          <a:noFill/>
-          <a:ln/>
-        </p:spPr>
-        <p:txBody>
-          <a:bodyPr wrap="square" lIns="0" tIns="0" rIns="0" bIns="0" rtlCol="0" anchor="ctr"/>
-          <a:lstStyle/>
-          <a:p>
-            <a:pPr marL="0" indent="0" algn="ctr">
-              <a:buNone/>
-            </a:pPr>
-            <a:r>
-              <a:rPr lang="en-US" sz="1100" b="1" dirty="0">
-                <a:solidFill>
-                  <a:srgbClr val="4F5DA3"/>
-                </a:solidFill>
-                <a:latin typeface="Consolas" pitchFamily="34" charset="0"/>
-                <a:ea typeface="Consolas" pitchFamily="34" charset="-122"/>
-                <a:cs typeface="Consolas" pitchFamily="34" charset="-120"/>
-              </a:rPr>
-              <a:t>24</a:t>
-            </a:r>
-            <a:endParaRPr lang="en-US" sz="1100" dirty="0"/>
-          </a:p>
-        </p:txBody>
-      </p:sp>
-      <p:sp>
-        <p:nvSpPr>
-          <p:cNvPr id="62" name="Text 60"/>
-          <p:cNvSpPr/>
-          <p:nvPr/>
-        </p:nvSpPr>
-        <p:spPr>
-          <a:xfrm>
-            <a:off x="2542032" y="4581144"/>
-            <a:ext cx="438912" cy="182880"/>
-          </a:xfrm>
-          <a:prstGeom prst="rect">
-            <a:avLst/>
-          </a:prstGeom>
-          <a:noFill/>
-          <a:ln/>
-        </p:spPr>
-        <p:txBody>
-          <a:bodyPr wrap="square" lIns="0" tIns="0" rIns="0" bIns="0" rtlCol="0" anchor="ctr"/>
-          <a:lstStyle/>
-          <a:p>
-            <a:pPr marL="0" indent="0" algn="ctr">
-              <a:buNone/>
-            </a:pPr>
-            <a:r>
-              <a:rPr lang="en-US" sz="750" dirty="0">
-                <a:solidFill>
-                  <a:srgbClr val="6B7280"/>
-                </a:solidFill>
-                <a:latin typeface="Calibri" pitchFamily="34" charset="0"/>
-                <a:ea typeface="Calibri" pitchFamily="34" charset="-122"/>
-                <a:cs typeface="Calibri" pitchFamily="34" charset="-120"/>
-              </a:rPr>
-              <a:t>Dia</a:t>
-            </a:r>
-            <a:endParaRPr lang="en-US" sz="750" dirty="0"/>
-          </a:p>
-        </p:txBody>
-      </p:sp>
-      <p:sp>
-        <p:nvSpPr>
-          <p:cNvPr id="63" name="Shape 61"/>
-          <p:cNvSpPr/>
-          <p:nvPr/>
-        </p:nvSpPr>
-        <p:spPr>
-          <a:xfrm>
-            <a:off x="3072384" y="4343400"/>
-            <a:ext cx="237744" cy="420624"/>
-          </a:xfrm>
-          <a:prstGeom prst="rect">
-            <a:avLst/>
-          </a:prstGeom>
-          <a:solidFill>
-            <a:srgbClr val="FFFFFF"/>
-          </a:solidFill>
-          <a:ln w="12700">
-            <a:solidFill>
-              <a:srgbClr val="FFFFFF"/>
-            </a:solidFill>
-            <a:prstDash val="solid"/>
-          </a:ln>
-        </p:spPr>
-      </p:sp>
-      <p:sp>
-        <p:nvSpPr>
-          <p:cNvPr id="64" name="Text 62"/>
-          <p:cNvSpPr/>
-          <p:nvPr/>
-        </p:nvSpPr>
-        <p:spPr>
-          <a:xfrm>
-            <a:off x="3072384" y="4343400"/>
-            <a:ext cx="237744" cy="237744"/>
-          </a:xfrm>
-          <a:prstGeom prst="rect">
-            <a:avLst/>
-          </a:prstGeom>
-          <a:noFill/>
-          <a:ln/>
-        </p:spPr>
-        <p:txBody>
-          <a:bodyPr wrap="square" lIns="0" tIns="0" rIns="0" bIns="0" rtlCol="0" anchor="ctr"/>
-          <a:lstStyle/>
-          <a:p>
-            <a:pPr marL="0" indent="0" algn="ctr">
-              <a:buNone/>
-            </a:pPr>
-            <a:r>
-              <a:rPr lang="en-US" sz="1100" b="1" dirty="0">
-                <a:solidFill>
-                  <a:srgbClr val="4F5DA3"/>
-                </a:solidFill>
-                <a:latin typeface="Consolas" pitchFamily="34" charset="0"/>
-                <a:ea typeface="Consolas" pitchFamily="34" charset="-122"/>
-                <a:cs typeface="Consolas" pitchFamily="34" charset="-120"/>
-              </a:rPr>
-              <a:t>–</a:t>
-            </a:r>
-            <a:endParaRPr lang="en-US" sz="1100" dirty="0"/>
-          </a:p>
-        </p:txBody>
-      </p:sp>
-      <p:sp>
-        <p:nvSpPr>
-          <p:cNvPr id="65" name="Shape 63"/>
-          <p:cNvSpPr/>
-          <p:nvPr/>
-        </p:nvSpPr>
-        <p:spPr>
-          <a:xfrm>
-            <a:off x="3401568" y="4343400"/>
-            <a:ext cx="950976" cy="420624"/>
-          </a:xfrm>
-          <a:prstGeom prst="rect">
-            <a:avLst/>
-          </a:prstGeom>
-          <a:solidFill>
-            <a:srgbClr val="EEF0FB"/>
-          </a:solidFill>
-          <a:ln w="12700">
-            <a:solidFill>
-              <a:srgbClr val="C5CCE8"/>
-            </a:solidFill>
-            <a:prstDash val="solid"/>
-          </a:ln>
-        </p:spPr>
-      </p:sp>
-      <p:sp>
-        <p:nvSpPr>
-          <p:cNvPr id="66" name="Text 64"/>
-          <p:cNvSpPr/>
-          <p:nvPr/>
-        </p:nvSpPr>
-        <p:spPr>
-          <a:xfrm>
-            <a:off x="3401568" y="4343400"/>
-            <a:ext cx="950976" cy="237744"/>
-          </a:xfrm>
-          <a:prstGeom prst="rect">
-            <a:avLst/>
-          </a:prstGeom>
-          <a:noFill/>
-          <a:ln/>
-        </p:spPr>
-        <p:txBody>
-          <a:bodyPr wrap="square" lIns="0" tIns="0" rIns="0" bIns="0" rtlCol="0" anchor="ctr"/>
-          <a:lstStyle/>
-          <a:p>
-            <a:pPr marL="0" indent="0" algn="ctr">
-              <a:buNone/>
-            </a:pPr>
-            <a:r>
-              <a:rPr lang="en-US" sz="1000" b="1" dirty="0">
-                <a:solidFill>
-                  <a:srgbClr val="4F5DA3"/>
-                </a:solidFill>
-                <a:latin typeface="Consolas" pitchFamily="34" charset="0"/>
-                <a:ea typeface="Consolas" pitchFamily="34" charset="-122"/>
-                <a:cs typeface="Consolas" pitchFamily="34" charset="-120"/>
-              </a:rPr>
-              <a:t>96E29B</a:t>
-            </a:r>
-            <a:endParaRPr lang="en-US" sz="1000" dirty="0"/>
-          </a:p>
-        </p:txBody>
-      </p:sp>
-      <p:sp>
-        <p:nvSpPr>
-          <p:cNvPr id="67" name="Text 65"/>
-          <p:cNvSpPr/>
-          <p:nvPr/>
-        </p:nvSpPr>
-        <p:spPr>
-          <a:xfrm>
-            <a:off x="3401568" y="4581144"/>
-            <a:ext cx="950976" cy="182880"/>
-          </a:xfrm>
-          <a:prstGeom prst="rect">
-            <a:avLst/>
-          </a:prstGeom>
-          <a:noFill/>
-          <a:ln/>
-        </p:spPr>
-        <p:txBody>
-          <a:bodyPr wrap="square" lIns="0" tIns="0" rIns="0" bIns="0" rtlCol="0" anchor="ctr"/>
-          <a:lstStyle/>
-          <a:p>
-            <a:pPr marL="0" indent="0" algn="ctr">
-              <a:buNone/>
-            </a:pPr>
-            <a:r>
-              <a:rPr lang="en-US" sz="750" dirty="0">
-                <a:solidFill>
-                  <a:srgbClr val="6B7280"/>
-                </a:solidFill>
-                <a:latin typeface="Calibri" pitchFamily="34" charset="0"/>
-                <a:ea typeface="Calibri" pitchFamily="34" charset="-122"/>
-                <a:cs typeface="Calibri" pitchFamily="34" charset="-120"/>
-              </a:rPr>
-              <a:t>HEX aleatório</a:t>
-            </a:r>
-            <a:endParaRPr lang="en-US" sz="750" dirty="0"/>
-          </a:p>
-        </p:txBody>
-      </p:sp>
-      <p:sp>
-        <p:nvSpPr>
-          <p:cNvPr id="68" name="Text 66"/>
-          <p:cNvSpPr/>
-          <p:nvPr/>
-        </p:nvSpPr>
-        <p:spPr>
-          <a:xfrm>
-            <a:off x="4626864" y="4407408"/>
-            <a:ext cx="4242816" cy="292608"/>
-          </a:xfrm>
-          <a:prstGeom prst="rect">
-            <a:avLst/>
-          </a:prstGeom>
-          <a:noFill/>
-          <a:ln/>
-        </p:spPr>
-        <p:txBody>
-          <a:bodyPr wrap="square" lIns="0" tIns="0" rIns="0" bIns="0" rtlCol="0" anchor="ctr"/>
-          <a:lstStyle/>
-          <a:p>
-            <a:pPr marL="0" indent="0">
-              <a:buNone/>
-            </a:pPr>
-            <a:r>
-              <a:rPr lang="en-US" sz="850" dirty="0">
-                <a:solidFill>
-                  <a:srgbClr val="6B7280"/>
-                </a:solidFill>
-                <a:latin typeface="Calibri" pitchFamily="34" charset="0"/>
-                <a:ea typeface="Calibri" pitchFamily="34" charset="-122"/>
-                <a:cs typeface="Calibri" pitchFamily="34" charset="-120"/>
-              </a:rPr>
-              <a:t>= Gerado via: 'CH' + date('Ymd') + '-' + strtoupper(substr(md5(uniqid()),0,6))</a:t>
             </a:r>
             <a:endParaRPr lang="en-US" sz="850" dirty="0"/>
           </a:p>

</xml_diff>